<commit_message>
docs: improve slide layout with key numbers and notebook references
</commit_message>
<xml_diff>
--- a/docs/Week2_Synthetic_Data_Deck_v2.pptx
+++ b/docs/Week2_Synthetic_Data_Deck_v2.pptx
@@ -3744,6 +3744,810 @@
         </p:nvSpPr>
         <p:spPr>
           <a:xfrm>
+            <a:off x="320040" y="5486400"/>
+            <a:ext cx="2841498" cy="621792"/>
+          </a:xfrm>
+          <a:prstGeom prst="rect">
+            <a:avLst/>
+          </a:prstGeom>
+          <a:solidFill>
+            <a:srgbClr val="132642"/>
+          </a:solidFill>
+          <a:ln>
+            <a:noFill/>
+          </a:ln>
+        </p:spPr>
+        <p:style>
+          <a:lnRef idx="1">
+            <a:schemeClr val="accent1"/>
+          </a:lnRef>
+          <a:fillRef idx="3">
+            <a:schemeClr val="accent1"/>
+          </a:fillRef>
+          <a:effectRef idx="2">
+            <a:schemeClr val="accent1"/>
+          </a:effectRef>
+          <a:fontRef idx="minor">
+            <a:schemeClr val="lt1"/>
+          </a:fontRef>
+        </p:style>
+        <p:txBody>
+          <a:bodyPr rtlCol="0" anchor="ctr"/>
+          <a:lstStyle/>
+          <a:p>
+            <a:pPr algn="ctr"/>
+          </a:p>
+        </p:txBody>
+      </p:sp>
+      <p:sp>
+        <p:nvSpPr>
+          <p:cNvPr id="11" name="Rectangle 10"/>
+          <p:cNvSpPr/>
+          <p:nvPr/>
+        </p:nvSpPr>
+        <p:spPr>
+          <a:xfrm>
+            <a:off x="320040" y="5486400"/>
+            <a:ext cx="2841498" cy="64008"/>
+          </a:xfrm>
+          <a:prstGeom prst="rect">
+            <a:avLst/>
+          </a:prstGeom>
+          <a:solidFill>
+            <a:srgbClr val="00B4D8"/>
+          </a:solidFill>
+          <a:ln>
+            <a:noFill/>
+          </a:ln>
+        </p:spPr>
+        <p:style>
+          <a:lnRef idx="1">
+            <a:schemeClr val="accent1"/>
+          </a:lnRef>
+          <a:fillRef idx="3">
+            <a:schemeClr val="accent1"/>
+          </a:fillRef>
+          <a:effectRef idx="2">
+            <a:schemeClr val="accent1"/>
+          </a:effectRef>
+          <a:fontRef idx="minor">
+            <a:schemeClr val="lt1"/>
+          </a:fontRef>
+        </p:style>
+        <p:txBody>
+          <a:bodyPr rtlCol="0" anchor="ctr"/>
+          <a:lstStyle/>
+          <a:p>
+            <a:pPr algn="ctr"/>
+          </a:p>
+        </p:txBody>
+      </p:sp>
+      <p:sp>
+        <p:nvSpPr>
+          <p:cNvPr id="12" name="TextBox 11"/>
+          <p:cNvSpPr txBox="1"/>
+          <p:nvPr/>
+        </p:nvSpPr>
+        <p:spPr>
+          <a:xfrm>
+            <a:off x="411479" y="5504688"/>
+            <a:ext cx="2658618" cy="320040"/>
+          </a:xfrm>
+          <a:prstGeom prst="rect">
+            <a:avLst/>
+          </a:prstGeom>
+          <a:noFill/>
+        </p:spPr>
+        <p:txBody>
+          <a:bodyPr wrap="square">
+            <a:spAutoFit/>
+          </a:bodyPr>
+          <a:lstStyle/>
+          <a:p>
+            <a:pPr algn="ctr"/>
+            <a:r>
+              <a:rPr sz="2000" b="1">
+                <a:solidFill>
+                  <a:srgbClr val="FF9F1C"/>
+                </a:solidFill>
+              </a:rPr>
+              <a:t>20,000</a:t>
+            </a:r>
+          </a:p>
+        </p:txBody>
+      </p:sp>
+      <p:sp>
+        <p:nvSpPr>
+          <p:cNvPr id="13" name="TextBox 12"/>
+          <p:cNvSpPr txBox="1"/>
+          <p:nvPr/>
+        </p:nvSpPr>
+        <p:spPr>
+          <a:xfrm>
+            <a:off x="411479" y="5833872"/>
+            <a:ext cx="2658618" cy="256032"/>
+          </a:xfrm>
+          <a:prstGeom prst="rect">
+            <a:avLst/>
+          </a:prstGeom>
+          <a:noFill/>
+        </p:spPr>
+        <p:txBody>
+          <a:bodyPr wrap="square">
+            <a:spAutoFit/>
+          </a:bodyPr>
+          <a:lstStyle/>
+          <a:p>
+            <a:pPr algn="ctr"/>
+            <a:r>
+              <a:rPr sz="1000" b="0">
+                <a:solidFill>
+                  <a:srgbClr val="C8E0F4"/>
+                </a:solidFill>
+              </a:rPr>
+              <a:t>Khách hàng mô phỏng</a:t>
+            </a:r>
+          </a:p>
+        </p:txBody>
+      </p:sp>
+      <p:sp>
+        <p:nvSpPr>
+          <p:cNvPr id="14" name="Rectangle 13"/>
+          <p:cNvSpPr/>
+          <p:nvPr/>
+        </p:nvSpPr>
+        <p:spPr>
+          <a:xfrm>
+            <a:off x="3207258" y="5486400"/>
+            <a:ext cx="2841498" cy="621792"/>
+          </a:xfrm>
+          <a:prstGeom prst="rect">
+            <a:avLst/>
+          </a:prstGeom>
+          <a:solidFill>
+            <a:srgbClr val="132642"/>
+          </a:solidFill>
+          <a:ln>
+            <a:noFill/>
+          </a:ln>
+        </p:spPr>
+        <p:style>
+          <a:lnRef idx="1">
+            <a:schemeClr val="accent1"/>
+          </a:lnRef>
+          <a:fillRef idx="3">
+            <a:schemeClr val="accent1"/>
+          </a:fillRef>
+          <a:effectRef idx="2">
+            <a:schemeClr val="accent1"/>
+          </a:effectRef>
+          <a:fontRef idx="minor">
+            <a:schemeClr val="lt1"/>
+          </a:fontRef>
+        </p:style>
+        <p:txBody>
+          <a:bodyPr rtlCol="0" anchor="ctr"/>
+          <a:lstStyle/>
+          <a:p>
+            <a:pPr algn="ctr"/>
+          </a:p>
+        </p:txBody>
+      </p:sp>
+      <p:sp>
+        <p:nvSpPr>
+          <p:cNvPr id="15" name="Rectangle 14"/>
+          <p:cNvSpPr/>
+          <p:nvPr/>
+        </p:nvSpPr>
+        <p:spPr>
+          <a:xfrm>
+            <a:off x="3207258" y="5486400"/>
+            <a:ext cx="2841498" cy="64008"/>
+          </a:xfrm>
+          <a:prstGeom prst="rect">
+            <a:avLst/>
+          </a:prstGeom>
+          <a:solidFill>
+            <a:srgbClr val="00B4D8"/>
+          </a:solidFill>
+          <a:ln>
+            <a:noFill/>
+          </a:ln>
+        </p:spPr>
+        <p:style>
+          <a:lnRef idx="1">
+            <a:schemeClr val="accent1"/>
+          </a:lnRef>
+          <a:fillRef idx="3">
+            <a:schemeClr val="accent1"/>
+          </a:fillRef>
+          <a:effectRef idx="2">
+            <a:schemeClr val="accent1"/>
+          </a:effectRef>
+          <a:fontRef idx="minor">
+            <a:schemeClr val="lt1"/>
+          </a:fontRef>
+        </p:style>
+        <p:txBody>
+          <a:bodyPr rtlCol="0" anchor="ctr"/>
+          <a:lstStyle/>
+          <a:p>
+            <a:pPr algn="ctr"/>
+          </a:p>
+        </p:txBody>
+      </p:sp>
+      <p:sp>
+        <p:nvSpPr>
+          <p:cNvPr id="16" name="TextBox 15"/>
+          <p:cNvSpPr txBox="1"/>
+          <p:nvPr/>
+        </p:nvSpPr>
+        <p:spPr>
+          <a:xfrm>
+            <a:off x="3298698" y="5504688"/>
+            <a:ext cx="2658618" cy="320040"/>
+          </a:xfrm>
+          <a:prstGeom prst="rect">
+            <a:avLst/>
+          </a:prstGeom>
+          <a:noFill/>
+        </p:spPr>
+        <p:txBody>
+          <a:bodyPr wrap="square">
+            <a:spAutoFit/>
+          </a:bodyPr>
+          <a:lstStyle/>
+          <a:p>
+            <a:pPr algn="ctr"/>
+            <a:r>
+              <a:rPr sz="2000" b="1">
+                <a:solidFill>
+                  <a:srgbClr val="FF9F1C"/>
+                </a:solidFill>
+              </a:rPr>
+              <a:t>9</a:t>
+            </a:r>
+          </a:p>
+        </p:txBody>
+      </p:sp>
+      <p:sp>
+        <p:nvSpPr>
+          <p:cNvPr id="17" name="TextBox 16"/>
+          <p:cNvSpPr txBox="1"/>
+          <p:nvPr/>
+        </p:nvSpPr>
+        <p:spPr>
+          <a:xfrm>
+            <a:off x="3298698" y="5833872"/>
+            <a:ext cx="2658618" cy="256032"/>
+          </a:xfrm>
+          <a:prstGeom prst="rect">
+            <a:avLst/>
+          </a:prstGeom>
+          <a:noFill/>
+        </p:spPr>
+        <p:txBody>
+          <a:bodyPr wrap="square">
+            <a:spAutoFit/>
+          </a:bodyPr>
+          <a:lstStyle/>
+          <a:p>
+            <a:pPr algn="ctr"/>
+            <a:r>
+              <a:rPr sz="1000" b="0">
+                <a:solidFill>
+                  <a:srgbClr val="C8E0F4"/>
+                </a:solidFill>
+              </a:rPr>
+              <a:t>Raw Features thiết kế</a:t>
+            </a:r>
+          </a:p>
+        </p:txBody>
+      </p:sp>
+      <p:sp>
+        <p:nvSpPr>
+          <p:cNvPr id="18" name="Rectangle 17"/>
+          <p:cNvSpPr/>
+          <p:nvPr/>
+        </p:nvSpPr>
+        <p:spPr>
+          <a:xfrm>
+            <a:off x="6094476" y="5486400"/>
+            <a:ext cx="2841498" cy="621792"/>
+          </a:xfrm>
+          <a:prstGeom prst="rect">
+            <a:avLst/>
+          </a:prstGeom>
+          <a:solidFill>
+            <a:srgbClr val="132642"/>
+          </a:solidFill>
+          <a:ln>
+            <a:noFill/>
+          </a:ln>
+        </p:spPr>
+        <p:style>
+          <a:lnRef idx="1">
+            <a:schemeClr val="accent1"/>
+          </a:lnRef>
+          <a:fillRef idx="3">
+            <a:schemeClr val="accent1"/>
+          </a:fillRef>
+          <a:effectRef idx="2">
+            <a:schemeClr val="accent1"/>
+          </a:effectRef>
+          <a:fontRef idx="minor">
+            <a:schemeClr val="lt1"/>
+          </a:fontRef>
+        </p:style>
+        <p:txBody>
+          <a:bodyPr rtlCol="0" anchor="ctr"/>
+          <a:lstStyle/>
+          <a:p>
+            <a:pPr algn="ctr"/>
+          </a:p>
+        </p:txBody>
+      </p:sp>
+      <p:sp>
+        <p:nvSpPr>
+          <p:cNvPr id="19" name="Rectangle 18"/>
+          <p:cNvSpPr/>
+          <p:nvPr/>
+        </p:nvSpPr>
+        <p:spPr>
+          <a:xfrm>
+            <a:off x="6094476" y="5486400"/>
+            <a:ext cx="2841498" cy="64008"/>
+          </a:xfrm>
+          <a:prstGeom prst="rect">
+            <a:avLst/>
+          </a:prstGeom>
+          <a:solidFill>
+            <a:srgbClr val="00B4D8"/>
+          </a:solidFill>
+          <a:ln>
+            <a:noFill/>
+          </a:ln>
+        </p:spPr>
+        <p:style>
+          <a:lnRef idx="1">
+            <a:schemeClr val="accent1"/>
+          </a:lnRef>
+          <a:fillRef idx="3">
+            <a:schemeClr val="accent1"/>
+          </a:fillRef>
+          <a:effectRef idx="2">
+            <a:schemeClr val="accent1"/>
+          </a:effectRef>
+          <a:fontRef idx="minor">
+            <a:schemeClr val="lt1"/>
+          </a:fontRef>
+        </p:style>
+        <p:txBody>
+          <a:bodyPr rtlCol="0" anchor="ctr"/>
+          <a:lstStyle/>
+          <a:p>
+            <a:pPr algn="ctr"/>
+          </a:p>
+        </p:txBody>
+      </p:sp>
+      <p:sp>
+        <p:nvSpPr>
+          <p:cNvPr id="20" name="TextBox 19"/>
+          <p:cNvSpPr txBox="1"/>
+          <p:nvPr/>
+        </p:nvSpPr>
+        <p:spPr>
+          <a:xfrm>
+            <a:off x="6185916" y="5504688"/>
+            <a:ext cx="2658618" cy="320040"/>
+          </a:xfrm>
+          <a:prstGeom prst="rect">
+            <a:avLst/>
+          </a:prstGeom>
+          <a:noFill/>
+        </p:spPr>
+        <p:txBody>
+          <a:bodyPr wrap="square">
+            <a:spAutoFit/>
+          </a:bodyPr>
+          <a:lstStyle/>
+          <a:p>
+            <a:pPr algn="ctr"/>
+            <a:r>
+              <a:rPr sz="2000" b="1">
+                <a:solidFill>
+                  <a:srgbClr val="FF9F1C"/>
+                </a:solidFill>
+              </a:rPr>
+              <a:t>2</a:t>
+            </a:r>
+          </a:p>
+        </p:txBody>
+      </p:sp>
+      <p:sp>
+        <p:nvSpPr>
+          <p:cNvPr id="21" name="TextBox 20"/>
+          <p:cNvSpPr txBox="1"/>
+          <p:nvPr/>
+        </p:nvSpPr>
+        <p:spPr>
+          <a:xfrm>
+            <a:off x="6185916" y="5833872"/>
+            <a:ext cx="2658618" cy="256032"/>
+          </a:xfrm>
+          <a:prstGeom prst="rect">
+            <a:avLst/>
+          </a:prstGeom>
+          <a:noFill/>
+        </p:spPr>
+        <p:txBody>
+          <a:bodyPr wrap="square">
+            <a:spAutoFit/>
+          </a:bodyPr>
+          <a:lstStyle/>
+          <a:p>
+            <a:pPr algn="ctr"/>
+            <a:r>
+              <a:rPr sz="1000" b="0">
+                <a:solidFill>
+                  <a:srgbClr val="C8E0F4"/>
+                </a:solidFill>
+              </a:rPr>
+              <a:t>Biến Kết quả (y_obs, y_rand)</a:t>
+            </a:r>
+          </a:p>
+        </p:txBody>
+      </p:sp>
+      <p:sp>
+        <p:nvSpPr>
+          <p:cNvPr id="22" name="Rectangle 21"/>
+          <p:cNvSpPr/>
+          <p:nvPr/>
+        </p:nvSpPr>
+        <p:spPr>
+          <a:xfrm>
+            <a:off x="8981694" y="5486400"/>
+            <a:ext cx="2841498" cy="621792"/>
+          </a:xfrm>
+          <a:prstGeom prst="rect">
+            <a:avLst/>
+          </a:prstGeom>
+          <a:solidFill>
+            <a:srgbClr val="132642"/>
+          </a:solidFill>
+          <a:ln>
+            <a:noFill/>
+          </a:ln>
+        </p:spPr>
+        <p:style>
+          <a:lnRef idx="1">
+            <a:schemeClr val="accent1"/>
+          </a:lnRef>
+          <a:fillRef idx="3">
+            <a:schemeClr val="accent1"/>
+          </a:fillRef>
+          <a:effectRef idx="2">
+            <a:schemeClr val="accent1"/>
+          </a:effectRef>
+          <a:fontRef idx="minor">
+            <a:schemeClr val="lt1"/>
+          </a:fontRef>
+        </p:style>
+        <p:txBody>
+          <a:bodyPr rtlCol="0" anchor="ctr"/>
+          <a:lstStyle/>
+          <a:p>
+            <a:pPr algn="ctr"/>
+          </a:p>
+        </p:txBody>
+      </p:sp>
+      <p:sp>
+        <p:nvSpPr>
+          <p:cNvPr id="23" name="Rectangle 22"/>
+          <p:cNvSpPr/>
+          <p:nvPr/>
+        </p:nvSpPr>
+        <p:spPr>
+          <a:xfrm>
+            <a:off x="8981694" y="5486400"/>
+            <a:ext cx="2841498" cy="64008"/>
+          </a:xfrm>
+          <a:prstGeom prst="rect">
+            <a:avLst/>
+          </a:prstGeom>
+          <a:solidFill>
+            <a:srgbClr val="00B4D8"/>
+          </a:solidFill>
+          <a:ln>
+            <a:noFill/>
+          </a:ln>
+        </p:spPr>
+        <p:style>
+          <a:lnRef idx="1">
+            <a:schemeClr val="accent1"/>
+          </a:lnRef>
+          <a:fillRef idx="3">
+            <a:schemeClr val="accent1"/>
+          </a:fillRef>
+          <a:effectRef idx="2">
+            <a:schemeClr val="accent1"/>
+          </a:effectRef>
+          <a:fontRef idx="minor">
+            <a:schemeClr val="lt1"/>
+          </a:fontRef>
+        </p:style>
+        <p:txBody>
+          <a:bodyPr rtlCol="0" anchor="ctr"/>
+          <a:lstStyle/>
+          <a:p>
+            <a:pPr algn="ctr"/>
+          </a:p>
+        </p:txBody>
+      </p:sp>
+      <p:sp>
+        <p:nvSpPr>
+          <p:cNvPr id="24" name="TextBox 23"/>
+          <p:cNvSpPr txBox="1"/>
+          <p:nvPr/>
+        </p:nvSpPr>
+        <p:spPr>
+          <a:xfrm>
+            <a:off x="9073134" y="5504688"/>
+            <a:ext cx="2658618" cy="320040"/>
+          </a:xfrm>
+          <a:prstGeom prst="rect">
+            <a:avLst/>
+          </a:prstGeom>
+          <a:noFill/>
+        </p:spPr>
+        <p:txBody>
+          <a:bodyPr wrap="square">
+            <a:spAutoFit/>
+          </a:bodyPr>
+          <a:lstStyle/>
+          <a:p>
+            <a:pPr algn="ctr"/>
+            <a:r>
+              <a:rPr sz="2000" b="1">
+                <a:solidFill>
+                  <a:srgbClr val="FF9F1C"/>
+                </a:solidFill>
+              </a:rPr>
+              <a:t>1</a:t>
+            </a:r>
+          </a:p>
+        </p:txBody>
+      </p:sp>
+      <p:sp>
+        <p:nvSpPr>
+          <p:cNvPr id="25" name="TextBox 24"/>
+          <p:cNvSpPr txBox="1"/>
+          <p:nvPr/>
+        </p:nvSpPr>
+        <p:spPr>
+          <a:xfrm>
+            <a:off x="9073134" y="5833872"/>
+            <a:ext cx="2658618" cy="256032"/>
+          </a:xfrm>
+          <a:prstGeom prst="rect">
+            <a:avLst/>
+          </a:prstGeom>
+          <a:noFill/>
+        </p:spPr>
+        <p:txBody>
+          <a:bodyPr wrap="square">
+            <a:spAutoFit/>
+          </a:bodyPr>
+          <a:lstStyle/>
+          <a:p>
+            <a:pPr algn="ctr"/>
+            <a:r>
+              <a:rPr sz="1000" b="0">
+                <a:solidFill>
+                  <a:srgbClr val="C8E0F4"/>
+                </a:solidFill>
+              </a:rPr>
+              <a:t>Ground Truth (true_ite)</a:t>
+            </a:r>
+          </a:p>
+        </p:txBody>
+      </p:sp>
+      <p:sp>
+        <p:nvSpPr>
+          <p:cNvPr id="26" name="Rectangle 25"/>
+          <p:cNvSpPr/>
+          <p:nvPr/>
+        </p:nvSpPr>
+        <p:spPr>
+          <a:xfrm>
+            <a:off x="320040" y="6172200"/>
+            <a:ext cx="11548872" cy="530352"/>
+          </a:xfrm>
+          <a:prstGeom prst="rect">
+            <a:avLst/>
+          </a:prstGeom>
+          <a:solidFill>
+            <a:srgbClr val="0A1A2E"/>
+          </a:solidFill>
+          <a:ln>
+            <a:noFill/>
+          </a:ln>
+        </p:spPr>
+        <p:style>
+          <a:lnRef idx="1">
+            <a:schemeClr val="accent1"/>
+          </a:lnRef>
+          <a:fillRef idx="3">
+            <a:schemeClr val="accent1"/>
+          </a:fillRef>
+          <a:effectRef idx="2">
+            <a:schemeClr val="accent1"/>
+          </a:effectRef>
+          <a:fontRef idx="minor">
+            <a:schemeClr val="lt1"/>
+          </a:fontRef>
+        </p:style>
+        <p:txBody>
+          <a:bodyPr rtlCol="0" anchor="ctr"/>
+          <a:lstStyle/>
+          <a:p>
+            <a:pPr algn="ctr"/>
+          </a:p>
+        </p:txBody>
+      </p:sp>
+      <p:sp>
+        <p:nvSpPr>
+          <p:cNvPr id="27" name="Rectangle 26"/>
+          <p:cNvSpPr/>
+          <p:nvPr/>
+        </p:nvSpPr>
+        <p:spPr>
+          <a:xfrm>
+            <a:off x="320040" y="6172200"/>
+            <a:ext cx="54864" cy="530352"/>
+          </a:xfrm>
+          <a:prstGeom prst="rect">
+            <a:avLst/>
+          </a:prstGeom>
+          <a:solidFill>
+            <a:srgbClr val="48CAA3"/>
+          </a:solidFill>
+          <a:ln>
+            <a:noFill/>
+          </a:ln>
+        </p:spPr>
+        <p:style>
+          <a:lnRef idx="1">
+            <a:schemeClr val="accent1"/>
+          </a:lnRef>
+          <a:fillRef idx="3">
+            <a:schemeClr val="accent1"/>
+          </a:fillRef>
+          <a:effectRef idx="2">
+            <a:schemeClr val="accent1"/>
+          </a:effectRef>
+          <a:fontRef idx="minor">
+            <a:schemeClr val="lt1"/>
+          </a:fontRef>
+        </p:style>
+        <p:txBody>
+          <a:bodyPr rtlCol="0" anchor="ctr"/>
+          <a:lstStyle/>
+          <a:p>
+            <a:pPr algn="ctr"/>
+          </a:p>
+        </p:txBody>
+      </p:sp>
+      <p:sp>
+        <p:nvSpPr>
+          <p:cNvPr id="28" name="TextBox 27"/>
+          <p:cNvSpPr txBox="1"/>
+          <p:nvPr/>
+        </p:nvSpPr>
+        <p:spPr>
+          <a:xfrm>
+            <a:off x="475488" y="6199632"/>
+            <a:ext cx="2286000" cy="411480"/>
+          </a:xfrm>
+          <a:prstGeom prst="rect">
+            <a:avLst/>
+          </a:prstGeom>
+          <a:noFill/>
+        </p:spPr>
+        <p:txBody>
+          <a:bodyPr wrap="square">
+            <a:spAutoFit/>
+          </a:bodyPr>
+          <a:lstStyle/>
+          <a:p>
+            <a:pPr algn="l"/>
+            <a:r>
+              <a:rPr sz="1100" b="1">
+                <a:solidFill>
+                  <a:srgbClr val="48CAA3"/>
+                </a:solidFill>
+              </a:rPr>
+              <a:t>📓  Xem tại Notebook: </a:t>
+            </a:r>
+          </a:p>
+        </p:txBody>
+      </p:sp>
+      <p:sp>
+        <p:nvSpPr>
+          <p:cNvPr id="29" name="TextBox 28"/>
+          <p:cNvSpPr txBox="1"/>
+          <p:nvPr/>
+        </p:nvSpPr>
+        <p:spPr>
+          <a:xfrm>
+            <a:off x="2743200" y="6199632"/>
+            <a:ext cx="5029200" cy="411480"/>
+          </a:xfrm>
+          <a:prstGeom prst="rect">
+            <a:avLst/>
+          </a:prstGeom>
+          <a:noFill/>
+        </p:spPr>
+        <p:txBody>
+          <a:bodyPr wrap="square">
+            <a:spAutoFit/>
+          </a:bodyPr>
+          <a:lstStyle/>
+          <a:p>
+            <a:pPr algn="l"/>
+            <a:r>
+              <a:rPr sz="1100" b="1">
+                <a:solidFill>
+                  <a:srgbClr val="FF9F1C"/>
+                </a:solidFill>
+              </a:rPr>
+              <a:t>2_complex_data_generation.ipynb  </a:t>
+            </a:r>
+          </a:p>
+        </p:txBody>
+      </p:sp>
+      <p:sp>
+        <p:nvSpPr>
+          <p:cNvPr id="30" name="TextBox 29"/>
+          <p:cNvSpPr txBox="1"/>
+          <p:nvPr/>
+        </p:nvSpPr>
+        <p:spPr>
+          <a:xfrm>
+            <a:off x="6949440" y="6199632"/>
+            <a:ext cx="4572000" cy="411480"/>
+          </a:xfrm>
+          <a:prstGeom prst="rect">
+            <a:avLst/>
+          </a:prstGeom>
+          <a:noFill/>
+        </p:spPr>
+        <p:txBody>
+          <a:bodyPr wrap="square">
+            <a:spAutoFit/>
+          </a:bodyPr>
+          <a:lstStyle/>
+          <a:p>
+            <a:pPr algn="l"/>
+            <a:r>
+              <a:rPr sz="1100" b="0">
+                <a:solidFill>
+                  <a:srgbClr val="C8E0F4"/>
+                </a:solidFill>
+              </a:rPr>
+              <a:t>| Mục: Cell 1-2: Import &amp; Tổng quan kiến trúc SCM</a:t>
+            </a:r>
+          </a:p>
+        </p:txBody>
+      </p:sp>
+      <p:sp>
+        <p:nvSpPr>
+          <p:cNvPr id="31" name="Rectangle 30"/>
+          <p:cNvSpPr/>
+          <p:nvPr/>
+        </p:nvSpPr>
+        <p:spPr>
+          <a:xfrm>
             <a:off x="0" y="6793992"/>
             <a:ext cx="12188952" cy="64008"/>
           </a:xfrm>
@@ -6003,6 +6807,194 @@
         </p:nvSpPr>
         <p:spPr>
           <a:xfrm>
+            <a:off x="320040" y="6172200"/>
+            <a:ext cx="11548872" cy="530352"/>
+          </a:xfrm>
+          <a:prstGeom prst="rect">
+            <a:avLst/>
+          </a:prstGeom>
+          <a:solidFill>
+            <a:srgbClr val="0A1A2E"/>
+          </a:solidFill>
+          <a:ln>
+            <a:noFill/>
+          </a:ln>
+        </p:spPr>
+        <p:style>
+          <a:lnRef idx="1">
+            <a:schemeClr val="accent1"/>
+          </a:lnRef>
+          <a:fillRef idx="3">
+            <a:schemeClr val="accent1"/>
+          </a:fillRef>
+          <a:effectRef idx="2">
+            <a:schemeClr val="accent1"/>
+          </a:effectRef>
+          <a:fontRef idx="minor">
+            <a:schemeClr val="lt1"/>
+          </a:fontRef>
+        </p:style>
+        <p:txBody>
+          <a:bodyPr rtlCol="0" anchor="ctr"/>
+          <a:lstStyle/>
+          <a:p>
+            <a:pPr algn="ctr"/>
+          </a:p>
+        </p:txBody>
+      </p:sp>
+      <p:sp>
+        <p:nvSpPr>
+          <p:cNvPr id="60" name="Rectangle 59"/>
+          <p:cNvSpPr/>
+          <p:nvPr/>
+        </p:nvSpPr>
+        <p:spPr>
+          <a:xfrm>
+            <a:off x="320040" y="6172200"/>
+            <a:ext cx="54864" cy="530352"/>
+          </a:xfrm>
+          <a:prstGeom prst="rect">
+            <a:avLst/>
+          </a:prstGeom>
+          <a:solidFill>
+            <a:srgbClr val="48CAA3"/>
+          </a:solidFill>
+          <a:ln>
+            <a:noFill/>
+          </a:ln>
+        </p:spPr>
+        <p:style>
+          <a:lnRef idx="1">
+            <a:schemeClr val="accent1"/>
+          </a:lnRef>
+          <a:fillRef idx="3">
+            <a:schemeClr val="accent1"/>
+          </a:fillRef>
+          <a:effectRef idx="2">
+            <a:schemeClr val="accent1"/>
+          </a:effectRef>
+          <a:fontRef idx="minor">
+            <a:schemeClr val="lt1"/>
+          </a:fontRef>
+        </p:style>
+        <p:txBody>
+          <a:bodyPr rtlCol="0" anchor="ctr"/>
+          <a:lstStyle/>
+          <a:p>
+            <a:pPr algn="ctr"/>
+          </a:p>
+        </p:txBody>
+      </p:sp>
+      <p:sp>
+        <p:nvSpPr>
+          <p:cNvPr id="61" name="TextBox 60"/>
+          <p:cNvSpPr txBox="1"/>
+          <p:nvPr/>
+        </p:nvSpPr>
+        <p:spPr>
+          <a:xfrm>
+            <a:off x="475488" y="6199632"/>
+            <a:ext cx="2286000" cy="411480"/>
+          </a:xfrm>
+          <a:prstGeom prst="rect">
+            <a:avLst/>
+          </a:prstGeom>
+          <a:noFill/>
+        </p:spPr>
+        <p:txBody>
+          <a:bodyPr wrap="square">
+            <a:spAutoFit/>
+          </a:bodyPr>
+          <a:lstStyle/>
+          <a:p>
+            <a:pPr algn="l"/>
+            <a:r>
+              <a:rPr sz="1100" b="1">
+                <a:solidFill>
+                  <a:srgbClr val="48CAA3"/>
+                </a:solidFill>
+              </a:rPr>
+              <a:t>📓  Xem tại Notebook: </a:t>
+            </a:r>
+          </a:p>
+        </p:txBody>
+      </p:sp>
+      <p:sp>
+        <p:nvSpPr>
+          <p:cNvPr id="62" name="TextBox 61"/>
+          <p:cNvSpPr txBox="1"/>
+          <p:nvPr/>
+        </p:nvSpPr>
+        <p:spPr>
+          <a:xfrm>
+            <a:off x="2743200" y="6199632"/>
+            <a:ext cx="5029200" cy="411480"/>
+          </a:xfrm>
+          <a:prstGeom prst="rect">
+            <a:avLst/>
+          </a:prstGeom>
+          <a:noFill/>
+        </p:spPr>
+        <p:txBody>
+          <a:bodyPr wrap="square">
+            <a:spAutoFit/>
+          </a:bodyPr>
+          <a:lstStyle/>
+          <a:p>
+            <a:pPr algn="l"/>
+            <a:r>
+              <a:rPr sz="1100" b="1">
+                <a:solidFill>
+                  <a:srgbClr val="FF9F1C"/>
+                </a:solidFill>
+              </a:rPr>
+              <a:t>2_complex_data_generation.ipynb  </a:t>
+            </a:r>
+          </a:p>
+        </p:txBody>
+      </p:sp>
+      <p:sp>
+        <p:nvSpPr>
+          <p:cNvPr id="63" name="TextBox 62"/>
+          <p:cNvSpPr txBox="1"/>
+          <p:nvPr/>
+        </p:nvSpPr>
+        <p:spPr>
+          <a:xfrm>
+            <a:off x="6949440" y="6199632"/>
+            <a:ext cx="4572000" cy="411480"/>
+          </a:xfrm>
+          <a:prstGeom prst="rect">
+            <a:avLst/>
+          </a:prstGeom>
+          <a:noFill/>
+        </p:spPr>
+        <p:txBody>
+          <a:bodyPr wrap="square">
+            <a:spAutoFit/>
+          </a:bodyPr>
+          <a:lstStyle/>
+          <a:p>
+            <a:pPr algn="l"/>
+            <a:r>
+              <a:rPr sz="1100" b="0">
+                <a:solidFill>
+                  <a:srgbClr val="C8E0F4"/>
+                </a:solidFill>
+              </a:rPr>
+              <a:t>| Mục: Cell 3: UserSimulator.__init__() — xem phần phân phối từng biến</a:t>
+            </a:r>
+          </a:p>
+        </p:txBody>
+      </p:sp>
+      <p:sp>
+        <p:nvSpPr>
+          <p:cNvPr id="64" name="Rectangle 63"/>
+          <p:cNvSpPr/>
+          <p:nvPr/>
+        </p:nvSpPr>
+        <p:spPr>
+          <a:xfrm>
             <a:off x="0" y="6793992"/>
             <a:ext cx="12188952" cy="64008"/>
           </a:xfrm>
@@ -6593,6 +7585,810 @@
         </p:nvSpPr>
         <p:spPr>
           <a:xfrm>
+            <a:off x="320040" y="5486400"/>
+            <a:ext cx="2841498" cy="621792"/>
+          </a:xfrm>
+          <a:prstGeom prst="rect">
+            <a:avLst/>
+          </a:prstGeom>
+          <a:solidFill>
+            <a:srgbClr val="132642"/>
+          </a:solidFill>
+          <a:ln>
+            <a:noFill/>
+          </a:ln>
+        </p:spPr>
+        <p:style>
+          <a:lnRef idx="1">
+            <a:schemeClr val="accent1"/>
+          </a:lnRef>
+          <a:fillRef idx="3">
+            <a:schemeClr val="accent1"/>
+          </a:fillRef>
+          <a:effectRef idx="2">
+            <a:schemeClr val="accent1"/>
+          </a:effectRef>
+          <a:fontRef idx="minor">
+            <a:schemeClr val="lt1"/>
+          </a:fontRef>
+        </p:style>
+        <p:txBody>
+          <a:bodyPr rtlCol="0" anchor="ctr"/>
+          <a:lstStyle/>
+          <a:p>
+            <a:pPr algn="ctr"/>
+          </a:p>
+        </p:txBody>
+      </p:sp>
+      <p:sp>
+        <p:nvSpPr>
+          <p:cNvPr id="14" name="Rectangle 13"/>
+          <p:cNvSpPr/>
+          <p:nvPr/>
+        </p:nvSpPr>
+        <p:spPr>
+          <a:xfrm>
+            <a:off x="320040" y="5486400"/>
+            <a:ext cx="2841498" cy="64008"/>
+          </a:xfrm>
+          <a:prstGeom prst="rect">
+            <a:avLst/>
+          </a:prstGeom>
+          <a:solidFill>
+            <a:srgbClr val="00B4D8"/>
+          </a:solidFill>
+          <a:ln>
+            <a:noFill/>
+          </a:ln>
+        </p:spPr>
+        <p:style>
+          <a:lnRef idx="1">
+            <a:schemeClr val="accent1"/>
+          </a:lnRef>
+          <a:fillRef idx="3">
+            <a:schemeClr val="accent1"/>
+          </a:fillRef>
+          <a:effectRef idx="2">
+            <a:schemeClr val="accent1"/>
+          </a:effectRef>
+          <a:fontRef idx="minor">
+            <a:schemeClr val="lt1"/>
+          </a:fontRef>
+        </p:style>
+        <p:txBody>
+          <a:bodyPr rtlCol="0" anchor="ctr"/>
+          <a:lstStyle/>
+          <a:p>
+            <a:pPr algn="ctr"/>
+          </a:p>
+        </p:txBody>
+      </p:sp>
+      <p:sp>
+        <p:nvSpPr>
+          <p:cNvPr id="15" name="TextBox 14"/>
+          <p:cNvSpPr txBox="1"/>
+          <p:nvPr/>
+        </p:nvSpPr>
+        <p:spPr>
+          <a:xfrm>
+            <a:off x="411479" y="5504688"/>
+            <a:ext cx="2658618" cy="320040"/>
+          </a:xfrm>
+          <a:prstGeom prst="rect">
+            <a:avLst/>
+          </a:prstGeom>
+          <a:noFill/>
+        </p:spPr>
+        <p:txBody>
+          <a:bodyPr wrap="square">
+            <a:spAutoFit/>
+          </a:bodyPr>
+          <a:lstStyle/>
+          <a:p>
+            <a:pPr algn="ctr"/>
+            <a:r>
+              <a:rPr sz="2000" b="1">
+                <a:solidFill>
+                  <a:srgbClr val="FF9F1C"/>
+                </a:solidFill>
+              </a:rPr>
+              <a:t>20%</a:t>
+            </a:r>
+          </a:p>
+        </p:txBody>
+      </p:sp>
+      <p:sp>
+        <p:nvSpPr>
+          <p:cNvPr id="16" name="TextBox 15"/>
+          <p:cNvSpPr txBox="1"/>
+          <p:nvPr/>
+        </p:nvSpPr>
+        <p:spPr>
+          <a:xfrm>
+            <a:off x="411479" y="5833872"/>
+            <a:ext cx="2658618" cy="256032"/>
+          </a:xfrm>
+          <a:prstGeom prst="rect">
+            <a:avLst/>
+          </a:prstGeom>
+          <a:noFill/>
+        </p:spPr>
+        <p:txBody>
+          <a:bodyPr wrap="square">
+            <a:spAutoFit/>
+          </a:bodyPr>
+          <a:lstStyle/>
+          <a:p>
+            <a:pPr algn="ctr"/>
+            <a:r>
+              <a:rPr sz="1000" b="0">
+                <a:solidFill>
+                  <a:srgbClr val="C8E0F4"/>
+                </a:solidFill>
+              </a:rPr>
+              <a:t>Tỷ lệ Rain Riders trong dataset</a:t>
+            </a:r>
+          </a:p>
+        </p:txBody>
+      </p:sp>
+      <p:sp>
+        <p:nvSpPr>
+          <p:cNvPr id="17" name="Rectangle 16"/>
+          <p:cNvSpPr/>
+          <p:nvPr/>
+        </p:nvSpPr>
+        <p:spPr>
+          <a:xfrm>
+            <a:off x="3207258" y="5486400"/>
+            <a:ext cx="2841498" cy="621792"/>
+          </a:xfrm>
+          <a:prstGeom prst="rect">
+            <a:avLst/>
+          </a:prstGeom>
+          <a:solidFill>
+            <a:srgbClr val="132642"/>
+          </a:solidFill>
+          <a:ln>
+            <a:noFill/>
+          </a:ln>
+        </p:spPr>
+        <p:style>
+          <a:lnRef idx="1">
+            <a:schemeClr val="accent1"/>
+          </a:lnRef>
+          <a:fillRef idx="3">
+            <a:schemeClr val="accent1"/>
+          </a:fillRef>
+          <a:effectRef idx="2">
+            <a:schemeClr val="accent1"/>
+          </a:effectRef>
+          <a:fontRef idx="minor">
+            <a:schemeClr val="lt1"/>
+          </a:fontRef>
+        </p:style>
+        <p:txBody>
+          <a:bodyPr rtlCol="0" anchor="ctr"/>
+          <a:lstStyle/>
+          <a:p>
+            <a:pPr algn="ctr"/>
+          </a:p>
+        </p:txBody>
+      </p:sp>
+      <p:sp>
+        <p:nvSpPr>
+          <p:cNvPr id="18" name="Rectangle 17"/>
+          <p:cNvSpPr/>
+          <p:nvPr/>
+        </p:nvSpPr>
+        <p:spPr>
+          <a:xfrm>
+            <a:off x="3207258" y="5486400"/>
+            <a:ext cx="2841498" cy="64008"/>
+          </a:xfrm>
+          <a:prstGeom prst="rect">
+            <a:avLst/>
+          </a:prstGeom>
+          <a:solidFill>
+            <a:srgbClr val="00B4D8"/>
+          </a:solidFill>
+          <a:ln>
+            <a:noFill/>
+          </a:ln>
+        </p:spPr>
+        <p:style>
+          <a:lnRef idx="1">
+            <a:schemeClr val="accent1"/>
+          </a:lnRef>
+          <a:fillRef idx="3">
+            <a:schemeClr val="accent1"/>
+          </a:fillRef>
+          <a:effectRef idx="2">
+            <a:schemeClr val="accent1"/>
+          </a:effectRef>
+          <a:fontRef idx="minor">
+            <a:schemeClr val="lt1"/>
+          </a:fontRef>
+        </p:style>
+        <p:txBody>
+          <a:bodyPr rtlCol="0" anchor="ctr"/>
+          <a:lstStyle/>
+          <a:p>
+            <a:pPr algn="ctr"/>
+          </a:p>
+        </p:txBody>
+      </p:sp>
+      <p:sp>
+        <p:nvSpPr>
+          <p:cNvPr id="19" name="TextBox 18"/>
+          <p:cNvSpPr txBox="1"/>
+          <p:nvPr/>
+        </p:nvSpPr>
+        <p:spPr>
+          <a:xfrm>
+            <a:off x="3298698" y="5504688"/>
+            <a:ext cx="2658618" cy="320040"/>
+          </a:xfrm>
+          <a:prstGeom prst="rect">
+            <a:avLst/>
+          </a:prstGeom>
+          <a:noFill/>
+        </p:spPr>
+        <p:txBody>
+          <a:bodyPr wrap="square">
+            <a:spAutoFit/>
+          </a:bodyPr>
+          <a:lstStyle/>
+          <a:p>
+            <a:pPr algn="ctr"/>
+            <a:r>
+              <a:rPr sz="2000" b="1">
+                <a:solidFill>
+                  <a:srgbClr val="FF9F1C"/>
+                </a:solidFill>
+              </a:rPr>
+              <a:t>5%</a:t>
+            </a:r>
+          </a:p>
+        </p:txBody>
+      </p:sp>
+      <p:sp>
+        <p:nvSpPr>
+          <p:cNvPr id="20" name="TextBox 19"/>
+          <p:cNvSpPr txBox="1"/>
+          <p:nvPr/>
+        </p:nvSpPr>
+        <p:spPr>
+          <a:xfrm>
+            <a:off x="3298698" y="5833872"/>
+            <a:ext cx="2658618" cy="256032"/>
+          </a:xfrm>
+          <a:prstGeom prst="rect">
+            <a:avLst/>
+          </a:prstGeom>
+          <a:noFill/>
+        </p:spPr>
+        <p:txBody>
+          <a:bodyPr wrap="square">
+            <a:spAutoFit/>
+          </a:bodyPr>
+          <a:lstStyle/>
+          <a:p>
+            <a:pPr algn="ctr"/>
+            <a:r>
+              <a:rPr sz="1000" b="0">
+                <a:solidFill>
+                  <a:srgbClr val="C8E0F4"/>
+                </a:solidFill>
+              </a:rPr>
+              <a:t>Tỷ lệ Airport Business</a:t>
+            </a:r>
+          </a:p>
+        </p:txBody>
+      </p:sp>
+      <p:sp>
+        <p:nvSpPr>
+          <p:cNvPr id="21" name="Rectangle 20"/>
+          <p:cNvSpPr/>
+          <p:nvPr/>
+        </p:nvSpPr>
+        <p:spPr>
+          <a:xfrm>
+            <a:off x="6094476" y="5486400"/>
+            <a:ext cx="2841498" cy="621792"/>
+          </a:xfrm>
+          <a:prstGeom prst="rect">
+            <a:avLst/>
+          </a:prstGeom>
+          <a:solidFill>
+            <a:srgbClr val="132642"/>
+          </a:solidFill>
+          <a:ln>
+            <a:noFill/>
+          </a:ln>
+        </p:spPr>
+        <p:style>
+          <a:lnRef idx="1">
+            <a:schemeClr val="accent1"/>
+          </a:lnRef>
+          <a:fillRef idx="3">
+            <a:schemeClr val="accent1"/>
+          </a:fillRef>
+          <a:effectRef idx="2">
+            <a:schemeClr val="accent1"/>
+          </a:effectRef>
+          <a:fontRef idx="minor">
+            <a:schemeClr val="lt1"/>
+          </a:fontRef>
+        </p:style>
+        <p:txBody>
+          <a:bodyPr rtlCol="0" anchor="ctr"/>
+          <a:lstStyle/>
+          <a:p>
+            <a:pPr algn="ctr"/>
+          </a:p>
+        </p:txBody>
+      </p:sp>
+      <p:sp>
+        <p:nvSpPr>
+          <p:cNvPr id="22" name="Rectangle 21"/>
+          <p:cNvSpPr/>
+          <p:nvPr/>
+        </p:nvSpPr>
+        <p:spPr>
+          <a:xfrm>
+            <a:off x="6094476" y="5486400"/>
+            <a:ext cx="2841498" cy="64008"/>
+          </a:xfrm>
+          <a:prstGeom prst="rect">
+            <a:avLst/>
+          </a:prstGeom>
+          <a:solidFill>
+            <a:srgbClr val="00B4D8"/>
+          </a:solidFill>
+          <a:ln>
+            <a:noFill/>
+          </a:ln>
+        </p:spPr>
+        <p:style>
+          <a:lnRef idx="1">
+            <a:schemeClr val="accent1"/>
+          </a:lnRef>
+          <a:fillRef idx="3">
+            <a:schemeClr val="accent1"/>
+          </a:fillRef>
+          <a:effectRef idx="2">
+            <a:schemeClr val="accent1"/>
+          </a:effectRef>
+          <a:fontRef idx="minor">
+            <a:schemeClr val="lt1"/>
+          </a:fontRef>
+        </p:style>
+        <p:txBody>
+          <a:bodyPr rtlCol="0" anchor="ctr"/>
+          <a:lstStyle/>
+          <a:p>
+            <a:pPr algn="ctr"/>
+          </a:p>
+        </p:txBody>
+      </p:sp>
+      <p:sp>
+        <p:nvSpPr>
+          <p:cNvPr id="23" name="TextBox 22"/>
+          <p:cNvSpPr txBox="1"/>
+          <p:nvPr/>
+        </p:nvSpPr>
+        <p:spPr>
+          <a:xfrm>
+            <a:off x="6185916" y="5504688"/>
+            <a:ext cx="2658618" cy="320040"/>
+          </a:xfrm>
+          <a:prstGeom prst="rect">
+            <a:avLst/>
+          </a:prstGeom>
+          <a:noFill/>
+        </p:spPr>
+        <p:txBody>
+          <a:bodyPr wrap="square">
+            <a:spAutoFit/>
+          </a:bodyPr>
+          <a:lstStyle/>
+          <a:p>
+            <a:pPr algn="ctr"/>
+            <a:r>
+              <a:rPr sz="2000" b="1">
+                <a:solidFill>
+                  <a:srgbClr val="FF9F1C"/>
+                </a:solidFill>
+              </a:rPr>
+              <a:t>~30%</a:t>
+            </a:r>
+          </a:p>
+        </p:txBody>
+      </p:sp>
+      <p:sp>
+        <p:nvSpPr>
+          <p:cNvPr id="24" name="TextBox 23"/>
+          <p:cNvSpPr txBox="1"/>
+          <p:nvPr/>
+        </p:nvSpPr>
+        <p:spPr>
+          <a:xfrm>
+            <a:off x="6185916" y="5833872"/>
+            <a:ext cx="2658618" cy="256032"/>
+          </a:xfrm>
+          <a:prstGeom prst="rect">
+            <a:avLst/>
+          </a:prstGeom>
+          <a:noFill/>
+        </p:spPr>
+        <p:txBody>
+          <a:bodyPr wrap="square">
+            <a:spAutoFit/>
+          </a:bodyPr>
+          <a:lstStyle/>
+          <a:p>
+            <a:pPr algn="ctr"/>
+            <a:r>
+              <a:rPr sz="1000" b="0">
+                <a:solidFill>
+                  <a:srgbClr val="C8E0F4"/>
+                </a:solidFill>
+              </a:rPr>
+              <a:t>Tỷ lệ ngoại ô (Persuadables chính)</a:t>
+            </a:r>
+          </a:p>
+        </p:txBody>
+      </p:sp>
+      <p:sp>
+        <p:nvSpPr>
+          <p:cNvPr id="25" name="Rectangle 24"/>
+          <p:cNvSpPr/>
+          <p:nvPr/>
+        </p:nvSpPr>
+        <p:spPr>
+          <a:xfrm>
+            <a:off x="8981694" y="5486400"/>
+            <a:ext cx="2841498" cy="621792"/>
+          </a:xfrm>
+          <a:prstGeom prst="rect">
+            <a:avLst/>
+          </a:prstGeom>
+          <a:solidFill>
+            <a:srgbClr val="132642"/>
+          </a:solidFill>
+          <a:ln>
+            <a:noFill/>
+          </a:ln>
+        </p:spPr>
+        <p:style>
+          <a:lnRef idx="1">
+            <a:schemeClr val="accent1"/>
+          </a:lnRef>
+          <a:fillRef idx="3">
+            <a:schemeClr val="accent1"/>
+          </a:fillRef>
+          <a:effectRef idx="2">
+            <a:schemeClr val="accent1"/>
+          </a:effectRef>
+          <a:fontRef idx="minor">
+            <a:schemeClr val="lt1"/>
+          </a:fontRef>
+        </p:style>
+        <p:txBody>
+          <a:bodyPr rtlCol="0" anchor="ctr"/>
+          <a:lstStyle/>
+          <a:p>
+            <a:pPr algn="ctr"/>
+          </a:p>
+        </p:txBody>
+      </p:sp>
+      <p:sp>
+        <p:nvSpPr>
+          <p:cNvPr id="26" name="Rectangle 25"/>
+          <p:cNvSpPr/>
+          <p:nvPr/>
+        </p:nvSpPr>
+        <p:spPr>
+          <a:xfrm>
+            <a:off x="8981694" y="5486400"/>
+            <a:ext cx="2841498" cy="64008"/>
+          </a:xfrm>
+          <a:prstGeom prst="rect">
+            <a:avLst/>
+          </a:prstGeom>
+          <a:solidFill>
+            <a:srgbClr val="00B4D8"/>
+          </a:solidFill>
+          <a:ln>
+            <a:noFill/>
+          </a:ln>
+        </p:spPr>
+        <p:style>
+          <a:lnRef idx="1">
+            <a:schemeClr val="accent1"/>
+          </a:lnRef>
+          <a:fillRef idx="3">
+            <a:schemeClr val="accent1"/>
+          </a:fillRef>
+          <a:effectRef idx="2">
+            <a:schemeClr val="accent1"/>
+          </a:effectRef>
+          <a:fontRef idx="minor">
+            <a:schemeClr val="lt1"/>
+          </a:fontRef>
+        </p:style>
+        <p:txBody>
+          <a:bodyPr rtlCol="0" anchor="ctr"/>
+          <a:lstStyle/>
+          <a:p>
+            <a:pPr algn="ctr"/>
+          </a:p>
+        </p:txBody>
+      </p:sp>
+      <p:sp>
+        <p:nvSpPr>
+          <p:cNvPr id="27" name="TextBox 26"/>
+          <p:cNvSpPr txBox="1"/>
+          <p:nvPr/>
+        </p:nvSpPr>
+        <p:spPr>
+          <a:xfrm>
+            <a:off x="9073134" y="5504688"/>
+            <a:ext cx="2658618" cy="320040"/>
+          </a:xfrm>
+          <a:prstGeom prst="rect">
+            <a:avLst/>
+          </a:prstGeom>
+          <a:noFill/>
+        </p:spPr>
+        <p:txBody>
+          <a:bodyPr wrap="square">
+            <a:spAutoFit/>
+          </a:bodyPr>
+          <a:lstStyle/>
+          <a:p>
+            <a:pPr algn="ctr"/>
+            <a:r>
+              <a:rPr sz="2000" b="1">
+                <a:solidFill>
+                  <a:srgbClr val="FF9F1C"/>
+                </a:solidFill>
+              </a:rPr>
+              <a:t>~45%</a:t>
+            </a:r>
+          </a:p>
+        </p:txBody>
+      </p:sp>
+      <p:sp>
+        <p:nvSpPr>
+          <p:cNvPr id="28" name="TextBox 27"/>
+          <p:cNvSpPr txBox="1"/>
+          <p:nvPr/>
+        </p:nvSpPr>
+        <p:spPr>
+          <a:xfrm>
+            <a:off x="9073134" y="5833872"/>
+            <a:ext cx="2658618" cy="256032"/>
+          </a:xfrm>
+          <a:prstGeom prst="rect">
+            <a:avLst/>
+          </a:prstGeom>
+          <a:noFill/>
+        </p:spPr>
+        <p:txBody>
+          <a:bodyPr wrap="square">
+            <a:spAutoFit/>
+          </a:bodyPr>
+          <a:lstStyle/>
+          <a:p>
+            <a:pPr algn="ctr"/>
+            <a:r>
+              <a:rPr sz="1000" b="0">
+                <a:solidFill>
+                  <a:srgbClr val="C8E0F4"/>
+                </a:solidFill>
+              </a:rPr>
+              <a:t>Rush Hour users (Sure-things chính)</a:t>
+            </a:r>
+          </a:p>
+        </p:txBody>
+      </p:sp>
+      <p:sp>
+        <p:nvSpPr>
+          <p:cNvPr id="29" name="Rectangle 28"/>
+          <p:cNvSpPr/>
+          <p:nvPr/>
+        </p:nvSpPr>
+        <p:spPr>
+          <a:xfrm>
+            <a:off x="320040" y="6172200"/>
+            <a:ext cx="11548872" cy="530352"/>
+          </a:xfrm>
+          <a:prstGeom prst="rect">
+            <a:avLst/>
+          </a:prstGeom>
+          <a:solidFill>
+            <a:srgbClr val="0A1A2E"/>
+          </a:solidFill>
+          <a:ln>
+            <a:noFill/>
+          </a:ln>
+        </p:spPr>
+        <p:style>
+          <a:lnRef idx="1">
+            <a:schemeClr val="accent1"/>
+          </a:lnRef>
+          <a:fillRef idx="3">
+            <a:schemeClr val="accent1"/>
+          </a:fillRef>
+          <a:effectRef idx="2">
+            <a:schemeClr val="accent1"/>
+          </a:effectRef>
+          <a:fontRef idx="minor">
+            <a:schemeClr val="lt1"/>
+          </a:fontRef>
+        </p:style>
+        <p:txBody>
+          <a:bodyPr rtlCol="0" anchor="ctr"/>
+          <a:lstStyle/>
+          <a:p>
+            <a:pPr algn="ctr"/>
+          </a:p>
+        </p:txBody>
+      </p:sp>
+      <p:sp>
+        <p:nvSpPr>
+          <p:cNvPr id="30" name="Rectangle 29"/>
+          <p:cNvSpPr/>
+          <p:nvPr/>
+        </p:nvSpPr>
+        <p:spPr>
+          <a:xfrm>
+            <a:off x="320040" y="6172200"/>
+            <a:ext cx="54864" cy="530352"/>
+          </a:xfrm>
+          <a:prstGeom prst="rect">
+            <a:avLst/>
+          </a:prstGeom>
+          <a:solidFill>
+            <a:srgbClr val="48CAA3"/>
+          </a:solidFill>
+          <a:ln>
+            <a:noFill/>
+          </a:ln>
+        </p:spPr>
+        <p:style>
+          <a:lnRef idx="1">
+            <a:schemeClr val="accent1"/>
+          </a:lnRef>
+          <a:fillRef idx="3">
+            <a:schemeClr val="accent1"/>
+          </a:fillRef>
+          <a:effectRef idx="2">
+            <a:schemeClr val="accent1"/>
+          </a:effectRef>
+          <a:fontRef idx="minor">
+            <a:schemeClr val="lt1"/>
+          </a:fontRef>
+        </p:style>
+        <p:txBody>
+          <a:bodyPr rtlCol="0" anchor="ctr"/>
+          <a:lstStyle/>
+          <a:p>
+            <a:pPr algn="ctr"/>
+          </a:p>
+        </p:txBody>
+      </p:sp>
+      <p:sp>
+        <p:nvSpPr>
+          <p:cNvPr id="31" name="TextBox 30"/>
+          <p:cNvSpPr txBox="1"/>
+          <p:nvPr/>
+        </p:nvSpPr>
+        <p:spPr>
+          <a:xfrm>
+            <a:off x="475488" y="6199632"/>
+            <a:ext cx="2286000" cy="411480"/>
+          </a:xfrm>
+          <a:prstGeom prst="rect">
+            <a:avLst/>
+          </a:prstGeom>
+          <a:noFill/>
+        </p:spPr>
+        <p:txBody>
+          <a:bodyPr wrap="square">
+            <a:spAutoFit/>
+          </a:bodyPr>
+          <a:lstStyle/>
+          <a:p>
+            <a:pPr algn="l"/>
+            <a:r>
+              <a:rPr sz="1100" b="1">
+                <a:solidFill>
+                  <a:srgbClr val="48CAA3"/>
+                </a:solidFill>
+              </a:rPr>
+              <a:t>📓  Xem tại Notebook: </a:t>
+            </a:r>
+          </a:p>
+        </p:txBody>
+      </p:sp>
+      <p:sp>
+        <p:nvSpPr>
+          <p:cNvPr id="32" name="TextBox 31"/>
+          <p:cNvSpPr txBox="1"/>
+          <p:nvPr/>
+        </p:nvSpPr>
+        <p:spPr>
+          <a:xfrm>
+            <a:off x="2743200" y="6199632"/>
+            <a:ext cx="5029200" cy="411480"/>
+          </a:xfrm>
+          <a:prstGeom prst="rect">
+            <a:avLst/>
+          </a:prstGeom>
+          <a:noFill/>
+        </p:spPr>
+        <p:txBody>
+          <a:bodyPr wrap="square">
+            <a:spAutoFit/>
+          </a:bodyPr>
+          <a:lstStyle/>
+          <a:p>
+            <a:pPr algn="l"/>
+            <a:r>
+              <a:rPr sz="1100" b="1">
+                <a:solidFill>
+                  <a:srgbClr val="FF9F1C"/>
+                </a:solidFill>
+              </a:rPr>
+              <a:t>2_complex_data_generation.ipynb  </a:t>
+            </a:r>
+          </a:p>
+        </p:txBody>
+      </p:sp>
+      <p:sp>
+        <p:nvSpPr>
+          <p:cNvPr id="33" name="TextBox 32"/>
+          <p:cNvSpPr txBox="1"/>
+          <p:nvPr/>
+        </p:nvSpPr>
+        <p:spPr>
+          <a:xfrm>
+            <a:off x="6949440" y="6199632"/>
+            <a:ext cx="4572000" cy="411480"/>
+          </a:xfrm>
+          <a:prstGeom prst="rect">
+            <a:avLst/>
+          </a:prstGeom>
+          <a:noFill/>
+        </p:spPr>
+        <p:txBody>
+          <a:bodyPr wrap="square">
+            <a:spAutoFit/>
+          </a:bodyPr>
+          <a:lstStyle/>
+          <a:p>
+            <a:pPr algn="l"/>
+            <a:r>
+              <a:rPr sz="1100" b="0">
+                <a:solidFill>
+                  <a:srgbClr val="C8E0F4"/>
+                </a:solidFill>
+              </a:rPr>
+              <a:t>| Mục: Cell 4: _inject_confounders() — biến nhiễu tác động lên treatment_obs</a:t>
+            </a:r>
+          </a:p>
+        </p:txBody>
+      </p:sp>
+      <p:sp>
+        <p:nvSpPr>
+          <p:cNvPr id="34" name="Rectangle 33"/>
+          <p:cNvSpPr/>
+          <p:nvPr/>
+        </p:nvSpPr>
+        <p:spPr>
+          <a:xfrm>
             <a:off x="0" y="6793992"/>
             <a:ext cx="12188952" cy="64008"/>
           </a:xfrm>
@@ -7192,6 +8988,810 @@
         </p:nvSpPr>
         <p:spPr>
           <a:xfrm>
+            <a:off x="320040" y="5486400"/>
+            <a:ext cx="2841498" cy="621792"/>
+          </a:xfrm>
+          <a:prstGeom prst="rect">
+            <a:avLst/>
+          </a:prstGeom>
+          <a:solidFill>
+            <a:srgbClr val="132642"/>
+          </a:solidFill>
+          <a:ln>
+            <a:noFill/>
+          </a:ln>
+        </p:spPr>
+        <p:style>
+          <a:lnRef idx="1">
+            <a:schemeClr val="accent1"/>
+          </a:lnRef>
+          <a:fillRef idx="3">
+            <a:schemeClr val="accent1"/>
+          </a:fillRef>
+          <a:effectRef idx="2">
+            <a:schemeClr val="accent1"/>
+          </a:effectRef>
+          <a:fontRef idx="minor">
+            <a:schemeClr val="lt1"/>
+          </a:fontRef>
+        </p:style>
+        <p:txBody>
+          <a:bodyPr rtlCol="0" anchor="ctr"/>
+          <a:lstStyle/>
+          <a:p>
+            <a:pPr algn="ctr"/>
+          </a:p>
+        </p:txBody>
+      </p:sp>
+      <p:sp>
+        <p:nvSpPr>
+          <p:cNvPr id="13" name="Rectangle 12"/>
+          <p:cNvSpPr/>
+          <p:nvPr/>
+        </p:nvSpPr>
+        <p:spPr>
+          <a:xfrm>
+            <a:off x="320040" y="5486400"/>
+            <a:ext cx="2841498" cy="64008"/>
+          </a:xfrm>
+          <a:prstGeom prst="rect">
+            <a:avLst/>
+          </a:prstGeom>
+          <a:solidFill>
+            <a:srgbClr val="00B4D8"/>
+          </a:solidFill>
+          <a:ln>
+            <a:noFill/>
+          </a:ln>
+        </p:spPr>
+        <p:style>
+          <a:lnRef idx="1">
+            <a:schemeClr val="accent1"/>
+          </a:lnRef>
+          <a:fillRef idx="3">
+            <a:schemeClr val="accent1"/>
+          </a:fillRef>
+          <a:effectRef idx="2">
+            <a:schemeClr val="accent1"/>
+          </a:effectRef>
+          <a:fontRef idx="minor">
+            <a:schemeClr val="lt1"/>
+          </a:fontRef>
+        </p:style>
+        <p:txBody>
+          <a:bodyPr rtlCol="0" anchor="ctr"/>
+          <a:lstStyle/>
+          <a:p>
+            <a:pPr algn="ctr"/>
+          </a:p>
+        </p:txBody>
+      </p:sp>
+      <p:sp>
+        <p:nvSpPr>
+          <p:cNvPr id="14" name="TextBox 13"/>
+          <p:cNvSpPr txBox="1"/>
+          <p:nvPr/>
+        </p:nvSpPr>
+        <p:spPr>
+          <a:xfrm>
+            <a:off x="411479" y="5504688"/>
+            <a:ext cx="2658618" cy="320040"/>
+          </a:xfrm>
+          <a:prstGeom prst="rect">
+            <a:avLst/>
+          </a:prstGeom>
+          <a:noFill/>
+        </p:spPr>
+        <p:txBody>
+          <a:bodyPr wrap="square">
+            <a:spAutoFit/>
+          </a:bodyPr>
+          <a:lstStyle/>
+          <a:p>
+            <a:pPr algn="ctr"/>
+            <a:r>
+              <a:rPr sz="2000" b="1">
+                <a:solidFill>
+                  <a:srgbClr val="FF9F1C"/>
+                </a:solidFill>
+              </a:rPr>
+              <a:t>ITE = +0.5</a:t>
+            </a:r>
+          </a:p>
+        </p:txBody>
+      </p:sp>
+      <p:sp>
+        <p:nvSpPr>
+          <p:cNvPr id="15" name="TextBox 14"/>
+          <p:cNvSpPr txBox="1"/>
+          <p:nvPr/>
+        </p:nvSpPr>
+        <p:spPr>
+          <a:xfrm>
+            <a:off x="411479" y="5833872"/>
+            <a:ext cx="2658618" cy="256032"/>
+          </a:xfrm>
+          <a:prstGeom prst="rect">
+            <a:avLst/>
+          </a:prstGeom>
+          <a:noFill/>
+        </p:spPr>
+        <p:txBody>
+          <a:bodyPr wrap="square">
+            <a:spAutoFit/>
+          </a:bodyPr>
+          <a:lstStyle/>
+          <a:p>
+            <a:pPr algn="ctr"/>
+            <a:r>
+              <a:rPr sz="1000" b="0">
+                <a:solidFill>
+                  <a:srgbClr val="C8E0F4"/>
+                </a:solidFill>
+              </a:rPr>
+              <a:t>Airport Business (kháng cao nhất)</a:t>
+            </a:r>
+          </a:p>
+        </p:txBody>
+      </p:sp>
+      <p:sp>
+        <p:nvSpPr>
+          <p:cNvPr id="16" name="Rectangle 15"/>
+          <p:cNvSpPr/>
+          <p:nvPr/>
+        </p:nvSpPr>
+        <p:spPr>
+          <a:xfrm>
+            <a:off x="3207258" y="5486400"/>
+            <a:ext cx="2841498" cy="621792"/>
+          </a:xfrm>
+          <a:prstGeom prst="rect">
+            <a:avLst/>
+          </a:prstGeom>
+          <a:solidFill>
+            <a:srgbClr val="132642"/>
+          </a:solidFill>
+          <a:ln>
+            <a:noFill/>
+          </a:ln>
+        </p:spPr>
+        <p:style>
+          <a:lnRef idx="1">
+            <a:schemeClr val="accent1"/>
+          </a:lnRef>
+          <a:fillRef idx="3">
+            <a:schemeClr val="accent1"/>
+          </a:fillRef>
+          <a:effectRef idx="2">
+            <a:schemeClr val="accent1"/>
+          </a:effectRef>
+          <a:fontRef idx="minor">
+            <a:schemeClr val="lt1"/>
+          </a:fontRef>
+        </p:style>
+        <p:txBody>
+          <a:bodyPr rtlCol="0" anchor="ctr"/>
+          <a:lstStyle/>
+          <a:p>
+            <a:pPr algn="ctr"/>
+          </a:p>
+        </p:txBody>
+      </p:sp>
+      <p:sp>
+        <p:nvSpPr>
+          <p:cNvPr id="17" name="Rectangle 16"/>
+          <p:cNvSpPr/>
+          <p:nvPr/>
+        </p:nvSpPr>
+        <p:spPr>
+          <a:xfrm>
+            <a:off x="3207258" y="5486400"/>
+            <a:ext cx="2841498" cy="64008"/>
+          </a:xfrm>
+          <a:prstGeom prst="rect">
+            <a:avLst/>
+          </a:prstGeom>
+          <a:solidFill>
+            <a:srgbClr val="00B4D8"/>
+          </a:solidFill>
+          <a:ln>
+            <a:noFill/>
+          </a:ln>
+        </p:spPr>
+        <p:style>
+          <a:lnRef idx="1">
+            <a:schemeClr val="accent1"/>
+          </a:lnRef>
+          <a:fillRef idx="3">
+            <a:schemeClr val="accent1"/>
+          </a:fillRef>
+          <a:effectRef idx="2">
+            <a:schemeClr val="accent1"/>
+          </a:effectRef>
+          <a:fontRef idx="minor">
+            <a:schemeClr val="lt1"/>
+          </a:fontRef>
+        </p:style>
+        <p:txBody>
+          <a:bodyPr rtlCol="0" anchor="ctr"/>
+          <a:lstStyle/>
+          <a:p>
+            <a:pPr algn="ctr"/>
+          </a:p>
+        </p:txBody>
+      </p:sp>
+      <p:sp>
+        <p:nvSpPr>
+          <p:cNvPr id="18" name="TextBox 17"/>
+          <p:cNvSpPr txBox="1"/>
+          <p:nvPr/>
+        </p:nvSpPr>
+        <p:spPr>
+          <a:xfrm>
+            <a:off x="3298698" y="5504688"/>
+            <a:ext cx="2658618" cy="320040"/>
+          </a:xfrm>
+          <a:prstGeom prst="rect">
+            <a:avLst/>
+          </a:prstGeom>
+          <a:noFill/>
+        </p:spPr>
+        <p:txBody>
+          <a:bodyPr wrap="square">
+            <a:spAutoFit/>
+          </a:bodyPr>
+          <a:lstStyle/>
+          <a:p>
+            <a:pPr algn="ctr"/>
+            <a:r>
+              <a:rPr sz="2000" b="1">
+                <a:solidFill>
+                  <a:srgbClr val="FF9F1C"/>
+                </a:solidFill>
+              </a:rPr>
+              <a:t>ITE = +1.0</a:t>
+            </a:r>
+          </a:p>
+        </p:txBody>
+      </p:sp>
+      <p:sp>
+        <p:nvSpPr>
+          <p:cNvPr id="19" name="TextBox 18"/>
+          <p:cNvSpPr txBox="1"/>
+          <p:nvPr/>
+        </p:nvSpPr>
+        <p:spPr>
+          <a:xfrm>
+            <a:off x="3298698" y="5833872"/>
+            <a:ext cx="2658618" cy="256032"/>
+          </a:xfrm>
+          <a:prstGeom prst="rect">
+            <a:avLst/>
+          </a:prstGeom>
+          <a:noFill/>
+        </p:spPr>
+        <p:txBody>
+          <a:bodyPr wrap="square">
+            <a:spAutoFit/>
+          </a:bodyPr>
+          <a:lstStyle/>
+          <a:p>
+            <a:pPr algn="ctr"/>
+            <a:r>
+              <a:rPr sz="1000" b="0">
+                <a:solidFill>
+                  <a:srgbClr val="C8E0F4"/>
+                </a:solidFill>
+              </a:rPr>
+              <a:t>Urban Regulars (đi làm)</a:t>
+            </a:r>
+          </a:p>
+        </p:txBody>
+      </p:sp>
+      <p:sp>
+        <p:nvSpPr>
+          <p:cNvPr id="20" name="Rectangle 19"/>
+          <p:cNvSpPr/>
+          <p:nvPr/>
+        </p:nvSpPr>
+        <p:spPr>
+          <a:xfrm>
+            <a:off x="6094476" y="5486400"/>
+            <a:ext cx="2841498" cy="621792"/>
+          </a:xfrm>
+          <a:prstGeom prst="rect">
+            <a:avLst/>
+          </a:prstGeom>
+          <a:solidFill>
+            <a:srgbClr val="132642"/>
+          </a:solidFill>
+          <a:ln>
+            <a:noFill/>
+          </a:ln>
+        </p:spPr>
+        <p:style>
+          <a:lnRef idx="1">
+            <a:schemeClr val="accent1"/>
+          </a:lnRef>
+          <a:fillRef idx="3">
+            <a:schemeClr val="accent1"/>
+          </a:fillRef>
+          <a:effectRef idx="2">
+            <a:schemeClr val="accent1"/>
+          </a:effectRef>
+          <a:fontRef idx="minor">
+            <a:schemeClr val="lt1"/>
+          </a:fontRef>
+        </p:style>
+        <p:txBody>
+          <a:bodyPr rtlCol="0" anchor="ctr"/>
+          <a:lstStyle/>
+          <a:p>
+            <a:pPr algn="ctr"/>
+          </a:p>
+        </p:txBody>
+      </p:sp>
+      <p:sp>
+        <p:nvSpPr>
+          <p:cNvPr id="21" name="Rectangle 20"/>
+          <p:cNvSpPr/>
+          <p:nvPr/>
+        </p:nvSpPr>
+        <p:spPr>
+          <a:xfrm>
+            <a:off x="6094476" y="5486400"/>
+            <a:ext cx="2841498" cy="64008"/>
+          </a:xfrm>
+          <a:prstGeom prst="rect">
+            <a:avLst/>
+          </a:prstGeom>
+          <a:solidFill>
+            <a:srgbClr val="00B4D8"/>
+          </a:solidFill>
+          <a:ln>
+            <a:noFill/>
+          </a:ln>
+        </p:spPr>
+        <p:style>
+          <a:lnRef idx="1">
+            <a:schemeClr val="accent1"/>
+          </a:lnRef>
+          <a:fillRef idx="3">
+            <a:schemeClr val="accent1"/>
+          </a:fillRef>
+          <a:effectRef idx="2">
+            <a:schemeClr val="accent1"/>
+          </a:effectRef>
+          <a:fontRef idx="minor">
+            <a:schemeClr val="lt1"/>
+          </a:fontRef>
+        </p:style>
+        <p:txBody>
+          <a:bodyPr rtlCol="0" anchor="ctr"/>
+          <a:lstStyle/>
+          <a:p>
+            <a:pPr algn="ctr"/>
+          </a:p>
+        </p:txBody>
+      </p:sp>
+      <p:sp>
+        <p:nvSpPr>
+          <p:cNvPr id="22" name="TextBox 21"/>
+          <p:cNvSpPr txBox="1"/>
+          <p:nvPr/>
+        </p:nvSpPr>
+        <p:spPr>
+          <a:xfrm>
+            <a:off x="6185916" y="5504688"/>
+            <a:ext cx="2658618" cy="320040"/>
+          </a:xfrm>
+          <a:prstGeom prst="rect">
+            <a:avLst/>
+          </a:prstGeom>
+          <a:noFill/>
+        </p:spPr>
+        <p:txBody>
+          <a:bodyPr wrap="square">
+            <a:spAutoFit/>
+          </a:bodyPr>
+          <a:lstStyle/>
+          <a:p>
+            <a:pPr algn="ctr"/>
+            <a:r>
+              <a:rPr sz="2000" b="1">
+                <a:solidFill>
+                  <a:srgbClr val="FF9F1C"/>
+                </a:solidFill>
+              </a:rPr>
+              <a:t>ITE = +2.5</a:t>
+            </a:r>
+          </a:p>
+        </p:txBody>
+      </p:sp>
+      <p:sp>
+        <p:nvSpPr>
+          <p:cNvPr id="23" name="TextBox 22"/>
+          <p:cNvSpPr txBox="1"/>
+          <p:nvPr/>
+        </p:nvSpPr>
+        <p:spPr>
+          <a:xfrm>
+            <a:off x="6185916" y="5833872"/>
+            <a:ext cx="2658618" cy="256032"/>
+          </a:xfrm>
+          <a:prstGeom prst="rect">
+            <a:avLst/>
+          </a:prstGeom>
+          <a:noFill/>
+        </p:spPr>
+        <p:txBody>
+          <a:bodyPr wrap="square">
+            <a:spAutoFit/>
+          </a:bodyPr>
+          <a:lstStyle/>
+          <a:p>
+            <a:pPr algn="ctr"/>
+            <a:r>
+              <a:rPr sz="1000" b="0">
+                <a:solidFill>
+                  <a:srgbClr val="C8E0F4"/>
+                </a:solidFill>
+              </a:rPr>
+              <a:t>Urban Leisure (nhạy cảm giá)</a:t>
+            </a:r>
+          </a:p>
+        </p:txBody>
+      </p:sp>
+      <p:sp>
+        <p:nvSpPr>
+          <p:cNvPr id="24" name="Rectangle 23"/>
+          <p:cNvSpPr/>
+          <p:nvPr/>
+        </p:nvSpPr>
+        <p:spPr>
+          <a:xfrm>
+            <a:off x="8981694" y="5486400"/>
+            <a:ext cx="2841498" cy="621792"/>
+          </a:xfrm>
+          <a:prstGeom prst="rect">
+            <a:avLst/>
+          </a:prstGeom>
+          <a:solidFill>
+            <a:srgbClr val="132642"/>
+          </a:solidFill>
+          <a:ln>
+            <a:noFill/>
+          </a:ln>
+        </p:spPr>
+        <p:style>
+          <a:lnRef idx="1">
+            <a:schemeClr val="accent1"/>
+          </a:lnRef>
+          <a:fillRef idx="3">
+            <a:schemeClr val="accent1"/>
+          </a:fillRef>
+          <a:effectRef idx="2">
+            <a:schemeClr val="accent1"/>
+          </a:effectRef>
+          <a:fontRef idx="minor">
+            <a:schemeClr val="lt1"/>
+          </a:fontRef>
+        </p:style>
+        <p:txBody>
+          <a:bodyPr rtlCol="0" anchor="ctr"/>
+          <a:lstStyle/>
+          <a:p>
+            <a:pPr algn="ctr"/>
+          </a:p>
+        </p:txBody>
+      </p:sp>
+      <p:sp>
+        <p:nvSpPr>
+          <p:cNvPr id="25" name="Rectangle 24"/>
+          <p:cNvSpPr/>
+          <p:nvPr/>
+        </p:nvSpPr>
+        <p:spPr>
+          <a:xfrm>
+            <a:off x="8981694" y="5486400"/>
+            <a:ext cx="2841498" cy="64008"/>
+          </a:xfrm>
+          <a:prstGeom prst="rect">
+            <a:avLst/>
+          </a:prstGeom>
+          <a:solidFill>
+            <a:srgbClr val="00B4D8"/>
+          </a:solidFill>
+          <a:ln>
+            <a:noFill/>
+          </a:ln>
+        </p:spPr>
+        <p:style>
+          <a:lnRef idx="1">
+            <a:schemeClr val="accent1"/>
+          </a:lnRef>
+          <a:fillRef idx="3">
+            <a:schemeClr val="accent1"/>
+          </a:fillRef>
+          <a:effectRef idx="2">
+            <a:schemeClr val="accent1"/>
+          </a:effectRef>
+          <a:fontRef idx="minor">
+            <a:schemeClr val="lt1"/>
+          </a:fontRef>
+        </p:style>
+        <p:txBody>
+          <a:bodyPr rtlCol="0" anchor="ctr"/>
+          <a:lstStyle/>
+          <a:p>
+            <a:pPr algn="ctr"/>
+          </a:p>
+        </p:txBody>
+      </p:sp>
+      <p:sp>
+        <p:nvSpPr>
+          <p:cNvPr id="26" name="TextBox 25"/>
+          <p:cNvSpPr txBox="1"/>
+          <p:nvPr/>
+        </p:nvSpPr>
+        <p:spPr>
+          <a:xfrm>
+            <a:off x="9073134" y="5504688"/>
+            <a:ext cx="2658618" cy="320040"/>
+          </a:xfrm>
+          <a:prstGeom prst="rect">
+            <a:avLst/>
+          </a:prstGeom>
+          <a:noFill/>
+        </p:spPr>
+        <p:txBody>
+          <a:bodyPr wrap="square">
+            <a:spAutoFit/>
+          </a:bodyPr>
+          <a:lstStyle/>
+          <a:p>
+            <a:pPr algn="ctr"/>
+            <a:r>
+              <a:rPr sz="2000" b="1">
+                <a:solidFill>
+                  <a:srgbClr val="FF9F1C"/>
+                </a:solidFill>
+              </a:rPr>
+              <a:t>ITE = +3.0</a:t>
+            </a:r>
+          </a:p>
+        </p:txBody>
+      </p:sp>
+      <p:sp>
+        <p:nvSpPr>
+          <p:cNvPr id="27" name="TextBox 26"/>
+          <p:cNvSpPr txBox="1"/>
+          <p:nvPr/>
+        </p:nvSpPr>
+        <p:spPr>
+          <a:xfrm>
+            <a:off x="9073134" y="5833872"/>
+            <a:ext cx="2658618" cy="256032"/>
+          </a:xfrm>
+          <a:prstGeom prst="rect">
+            <a:avLst/>
+          </a:prstGeom>
+          <a:noFill/>
+        </p:spPr>
+        <p:txBody>
+          <a:bodyPr wrap="square">
+            <a:spAutoFit/>
+          </a:bodyPr>
+          <a:lstStyle/>
+          <a:p>
+            <a:pPr algn="ctr"/>
+            <a:r>
+              <a:rPr sz="1000" b="0">
+                <a:solidFill>
+                  <a:srgbClr val="C8E0F4"/>
+                </a:solidFill>
+              </a:rPr>
+              <a:t>Suburban Occasionals (nhạy nhất)</a:t>
+            </a:r>
+          </a:p>
+        </p:txBody>
+      </p:sp>
+      <p:sp>
+        <p:nvSpPr>
+          <p:cNvPr id="28" name="Rectangle 27"/>
+          <p:cNvSpPr/>
+          <p:nvPr/>
+        </p:nvSpPr>
+        <p:spPr>
+          <a:xfrm>
+            <a:off x="320040" y="6172200"/>
+            <a:ext cx="11548872" cy="530352"/>
+          </a:xfrm>
+          <a:prstGeom prst="rect">
+            <a:avLst/>
+          </a:prstGeom>
+          <a:solidFill>
+            <a:srgbClr val="0A1A2E"/>
+          </a:solidFill>
+          <a:ln>
+            <a:noFill/>
+          </a:ln>
+        </p:spPr>
+        <p:style>
+          <a:lnRef idx="1">
+            <a:schemeClr val="accent1"/>
+          </a:lnRef>
+          <a:fillRef idx="3">
+            <a:schemeClr val="accent1"/>
+          </a:fillRef>
+          <a:effectRef idx="2">
+            <a:schemeClr val="accent1"/>
+          </a:effectRef>
+          <a:fontRef idx="minor">
+            <a:schemeClr val="lt1"/>
+          </a:fontRef>
+        </p:style>
+        <p:txBody>
+          <a:bodyPr rtlCol="0" anchor="ctr"/>
+          <a:lstStyle/>
+          <a:p>
+            <a:pPr algn="ctr"/>
+          </a:p>
+        </p:txBody>
+      </p:sp>
+      <p:sp>
+        <p:nvSpPr>
+          <p:cNvPr id="29" name="Rectangle 28"/>
+          <p:cNvSpPr/>
+          <p:nvPr/>
+        </p:nvSpPr>
+        <p:spPr>
+          <a:xfrm>
+            <a:off x="320040" y="6172200"/>
+            <a:ext cx="54864" cy="530352"/>
+          </a:xfrm>
+          <a:prstGeom prst="rect">
+            <a:avLst/>
+          </a:prstGeom>
+          <a:solidFill>
+            <a:srgbClr val="48CAA3"/>
+          </a:solidFill>
+          <a:ln>
+            <a:noFill/>
+          </a:ln>
+        </p:spPr>
+        <p:style>
+          <a:lnRef idx="1">
+            <a:schemeClr val="accent1"/>
+          </a:lnRef>
+          <a:fillRef idx="3">
+            <a:schemeClr val="accent1"/>
+          </a:fillRef>
+          <a:effectRef idx="2">
+            <a:schemeClr val="accent1"/>
+          </a:effectRef>
+          <a:fontRef idx="minor">
+            <a:schemeClr val="lt1"/>
+          </a:fontRef>
+        </p:style>
+        <p:txBody>
+          <a:bodyPr rtlCol="0" anchor="ctr"/>
+          <a:lstStyle/>
+          <a:p>
+            <a:pPr algn="ctr"/>
+          </a:p>
+        </p:txBody>
+      </p:sp>
+      <p:sp>
+        <p:nvSpPr>
+          <p:cNvPr id="30" name="TextBox 29"/>
+          <p:cNvSpPr txBox="1"/>
+          <p:nvPr/>
+        </p:nvSpPr>
+        <p:spPr>
+          <a:xfrm>
+            <a:off x="475488" y="6199632"/>
+            <a:ext cx="2286000" cy="411480"/>
+          </a:xfrm>
+          <a:prstGeom prst="rect">
+            <a:avLst/>
+          </a:prstGeom>
+          <a:noFill/>
+        </p:spPr>
+        <p:txBody>
+          <a:bodyPr wrap="square">
+            <a:spAutoFit/>
+          </a:bodyPr>
+          <a:lstStyle/>
+          <a:p>
+            <a:pPr algn="l"/>
+            <a:r>
+              <a:rPr sz="1100" b="1">
+                <a:solidFill>
+                  <a:srgbClr val="48CAA3"/>
+                </a:solidFill>
+              </a:rPr>
+              <a:t>📓  Xem tại Notebook: </a:t>
+            </a:r>
+          </a:p>
+        </p:txBody>
+      </p:sp>
+      <p:sp>
+        <p:nvSpPr>
+          <p:cNvPr id="31" name="TextBox 30"/>
+          <p:cNvSpPr txBox="1"/>
+          <p:nvPr/>
+        </p:nvSpPr>
+        <p:spPr>
+          <a:xfrm>
+            <a:off x="2743200" y="6199632"/>
+            <a:ext cx="5029200" cy="411480"/>
+          </a:xfrm>
+          <a:prstGeom prst="rect">
+            <a:avLst/>
+          </a:prstGeom>
+          <a:noFill/>
+        </p:spPr>
+        <p:txBody>
+          <a:bodyPr wrap="square">
+            <a:spAutoFit/>
+          </a:bodyPr>
+          <a:lstStyle/>
+          <a:p>
+            <a:pPr algn="l"/>
+            <a:r>
+              <a:rPr sz="1100" b="1">
+                <a:solidFill>
+                  <a:srgbClr val="FF9F1C"/>
+                </a:solidFill>
+              </a:rPr>
+              <a:t>2_complex_data_generation.ipynb  </a:t>
+            </a:r>
+          </a:p>
+        </p:txBody>
+      </p:sp>
+      <p:sp>
+        <p:nvSpPr>
+          <p:cNvPr id="32" name="TextBox 31"/>
+          <p:cNvSpPr txBox="1"/>
+          <p:nvPr/>
+        </p:nvSpPr>
+        <p:spPr>
+          <a:xfrm>
+            <a:off x="6949440" y="6199632"/>
+            <a:ext cx="4572000" cy="411480"/>
+          </a:xfrm>
+          <a:prstGeom prst="rect">
+            <a:avLst/>
+          </a:prstGeom>
+          <a:noFill/>
+        </p:spPr>
+        <p:txBody>
+          <a:bodyPr wrap="square">
+            <a:spAutoFit/>
+          </a:bodyPr>
+          <a:lstStyle/>
+          <a:p>
+            <a:pPr algn="l"/>
+            <a:r>
+              <a:rPr sz="1100" b="0">
+                <a:solidFill>
+                  <a:srgbClr val="C8E0F4"/>
+                </a:solidFill>
+              </a:rPr>
+              <a:t>| Mục: Cell 5: _compute_ite() — phương trình Causal Rules + true_ite</a:t>
+            </a:r>
+          </a:p>
+        </p:txBody>
+      </p:sp>
+      <p:sp>
+        <p:nvSpPr>
+          <p:cNvPr id="33" name="Rectangle 32"/>
+          <p:cNvSpPr/>
+          <p:nvPr/>
+        </p:nvSpPr>
+        <p:spPr>
+          <a:xfrm>
             <a:off x="0" y="6793992"/>
             <a:ext cx="12188952" cy="64008"/>
           </a:xfrm>
@@ -7759,6 +10359,810 @@
         </p:nvSpPr>
         <p:spPr>
           <a:xfrm>
+            <a:off x="320040" y="5486400"/>
+            <a:ext cx="2841498" cy="621792"/>
+          </a:xfrm>
+          <a:prstGeom prst="rect">
+            <a:avLst/>
+          </a:prstGeom>
+          <a:solidFill>
+            <a:srgbClr val="132642"/>
+          </a:solidFill>
+          <a:ln>
+            <a:noFill/>
+          </a:ln>
+        </p:spPr>
+        <p:style>
+          <a:lnRef idx="1">
+            <a:schemeClr val="accent1"/>
+          </a:lnRef>
+          <a:fillRef idx="3">
+            <a:schemeClr val="accent1"/>
+          </a:fillRef>
+          <a:effectRef idx="2">
+            <a:schemeClr val="accent1"/>
+          </a:effectRef>
+          <a:fontRef idx="minor">
+            <a:schemeClr val="lt1"/>
+          </a:fontRef>
+        </p:style>
+        <p:txBody>
+          <a:bodyPr rtlCol="0" anchor="ctr"/>
+          <a:lstStyle/>
+          <a:p>
+            <a:pPr algn="ctr"/>
+          </a:p>
+        </p:txBody>
+      </p:sp>
+      <p:sp>
+        <p:nvSpPr>
+          <p:cNvPr id="14" name="Rectangle 13"/>
+          <p:cNvSpPr/>
+          <p:nvPr/>
+        </p:nvSpPr>
+        <p:spPr>
+          <a:xfrm>
+            <a:off x="320040" y="5486400"/>
+            <a:ext cx="2841498" cy="64008"/>
+          </a:xfrm>
+          <a:prstGeom prst="rect">
+            <a:avLst/>
+          </a:prstGeom>
+          <a:solidFill>
+            <a:srgbClr val="00B4D8"/>
+          </a:solidFill>
+          <a:ln>
+            <a:noFill/>
+          </a:ln>
+        </p:spPr>
+        <p:style>
+          <a:lnRef idx="1">
+            <a:schemeClr val="accent1"/>
+          </a:lnRef>
+          <a:fillRef idx="3">
+            <a:schemeClr val="accent1"/>
+          </a:fillRef>
+          <a:effectRef idx="2">
+            <a:schemeClr val="accent1"/>
+          </a:effectRef>
+          <a:fontRef idx="minor">
+            <a:schemeClr val="lt1"/>
+          </a:fontRef>
+        </p:style>
+        <p:txBody>
+          <a:bodyPr rtlCol="0" anchor="ctr"/>
+          <a:lstStyle/>
+          <a:p>
+            <a:pPr algn="ctr"/>
+          </a:p>
+        </p:txBody>
+      </p:sp>
+      <p:sp>
+        <p:nvSpPr>
+          <p:cNvPr id="15" name="TextBox 14"/>
+          <p:cNvSpPr txBox="1"/>
+          <p:nvPr/>
+        </p:nvSpPr>
+        <p:spPr>
+          <a:xfrm>
+            <a:off x="411479" y="5504688"/>
+            <a:ext cx="2658618" cy="320040"/>
+          </a:xfrm>
+          <a:prstGeom prst="rect">
+            <a:avLst/>
+          </a:prstGeom>
+          <a:noFill/>
+        </p:spPr>
+        <p:txBody>
+          <a:bodyPr wrap="square">
+            <a:spAutoFit/>
+          </a:bodyPr>
+          <a:lstStyle/>
+          <a:p>
+            <a:pPr algn="ctr"/>
+            <a:r>
+              <a:rPr sz="2000" b="1">
+                <a:solidFill>
+                  <a:srgbClr val="FF9F1C"/>
+                </a:solidFill>
+              </a:rPr>
+              <a:t>y_obs</a:t>
+            </a:r>
+          </a:p>
+        </p:txBody>
+      </p:sp>
+      <p:sp>
+        <p:nvSpPr>
+          <p:cNvPr id="16" name="TextBox 15"/>
+          <p:cNvSpPr txBox="1"/>
+          <p:nvPr/>
+        </p:nvSpPr>
+        <p:spPr>
+          <a:xfrm>
+            <a:off x="411479" y="5833872"/>
+            <a:ext cx="2658618" cy="256032"/>
+          </a:xfrm>
+          <a:prstGeom prst="rect">
+            <a:avLst/>
+          </a:prstGeom>
+          <a:noFill/>
+        </p:spPr>
+        <p:txBody>
+          <a:bodyPr wrap="square">
+            <a:spAutoFit/>
+          </a:bodyPr>
+          <a:lstStyle/>
+          <a:p>
+            <a:pPr algn="ctr"/>
+            <a:r>
+              <a:rPr sz="1000" b="0">
+                <a:solidFill>
+                  <a:srgbClr val="C8E0F4"/>
+                </a:solidFill>
+              </a:rPr>
+              <a:t>Môi trường quan sát (bị nhiễu)</a:t>
+            </a:r>
+          </a:p>
+        </p:txBody>
+      </p:sp>
+      <p:sp>
+        <p:nvSpPr>
+          <p:cNvPr id="17" name="Rectangle 16"/>
+          <p:cNvSpPr/>
+          <p:nvPr/>
+        </p:nvSpPr>
+        <p:spPr>
+          <a:xfrm>
+            <a:off x="3207258" y="5486400"/>
+            <a:ext cx="2841498" cy="621792"/>
+          </a:xfrm>
+          <a:prstGeom prst="rect">
+            <a:avLst/>
+          </a:prstGeom>
+          <a:solidFill>
+            <a:srgbClr val="132642"/>
+          </a:solidFill>
+          <a:ln>
+            <a:noFill/>
+          </a:ln>
+        </p:spPr>
+        <p:style>
+          <a:lnRef idx="1">
+            <a:schemeClr val="accent1"/>
+          </a:lnRef>
+          <a:fillRef idx="3">
+            <a:schemeClr val="accent1"/>
+          </a:fillRef>
+          <a:effectRef idx="2">
+            <a:schemeClr val="accent1"/>
+          </a:effectRef>
+          <a:fontRef idx="minor">
+            <a:schemeClr val="lt1"/>
+          </a:fontRef>
+        </p:style>
+        <p:txBody>
+          <a:bodyPr rtlCol="0" anchor="ctr"/>
+          <a:lstStyle/>
+          <a:p>
+            <a:pPr algn="ctr"/>
+          </a:p>
+        </p:txBody>
+      </p:sp>
+      <p:sp>
+        <p:nvSpPr>
+          <p:cNvPr id="18" name="Rectangle 17"/>
+          <p:cNvSpPr/>
+          <p:nvPr/>
+        </p:nvSpPr>
+        <p:spPr>
+          <a:xfrm>
+            <a:off x="3207258" y="5486400"/>
+            <a:ext cx="2841498" cy="64008"/>
+          </a:xfrm>
+          <a:prstGeom prst="rect">
+            <a:avLst/>
+          </a:prstGeom>
+          <a:solidFill>
+            <a:srgbClr val="00B4D8"/>
+          </a:solidFill>
+          <a:ln>
+            <a:noFill/>
+          </a:ln>
+        </p:spPr>
+        <p:style>
+          <a:lnRef idx="1">
+            <a:schemeClr val="accent1"/>
+          </a:lnRef>
+          <a:fillRef idx="3">
+            <a:schemeClr val="accent1"/>
+          </a:fillRef>
+          <a:effectRef idx="2">
+            <a:schemeClr val="accent1"/>
+          </a:effectRef>
+          <a:fontRef idx="minor">
+            <a:schemeClr val="lt1"/>
+          </a:fontRef>
+        </p:style>
+        <p:txBody>
+          <a:bodyPr rtlCol="0" anchor="ctr"/>
+          <a:lstStyle/>
+          <a:p>
+            <a:pPr algn="ctr"/>
+          </a:p>
+        </p:txBody>
+      </p:sp>
+      <p:sp>
+        <p:nvSpPr>
+          <p:cNvPr id="19" name="TextBox 18"/>
+          <p:cNvSpPr txBox="1"/>
+          <p:nvPr/>
+        </p:nvSpPr>
+        <p:spPr>
+          <a:xfrm>
+            <a:off x="3298698" y="5504688"/>
+            <a:ext cx="2658618" cy="320040"/>
+          </a:xfrm>
+          <a:prstGeom prst="rect">
+            <a:avLst/>
+          </a:prstGeom>
+          <a:noFill/>
+        </p:spPr>
+        <p:txBody>
+          <a:bodyPr wrap="square">
+            <a:spAutoFit/>
+          </a:bodyPr>
+          <a:lstStyle/>
+          <a:p>
+            <a:pPr algn="ctr"/>
+            <a:r>
+              <a:rPr sz="2000" b="1">
+                <a:solidFill>
+                  <a:srgbClr val="FF9F1C"/>
+                </a:solidFill>
+              </a:rPr>
+              <a:t>y_rand</a:t>
+            </a:r>
+          </a:p>
+        </p:txBody>
+      </p:sp>
+      <p:sp>
+        <p:nvSpPr>
+          <p:cNvPr id="20" name="TextBox 19"/>
+          <p:cNvSpPr txBox="1"/>
+          <p:nvPr/>
+        </p:nvSpPr>
+        <p:spPr>
+          <a:xfrm>
+            <a:off x="3298698" y="5833872"/>
+            <a:ext cx="2658618" cy="256032"/>
+          </a:xfrm>
+          <a:prstGeom prst="rect">
+            <a:avLst/>
+          </a:prstGeom>
+          <a:noFill/>
+        </p:spPr>
+        <p:txBody>
+          <a:bodyPr wrap="square">
+            <a:spAutoFit/>
+          </a:bodyPr>
+          <a:lstStyle/>
+          <a:p>
+            <a:pPr algn="ctr"/>
+            <a:r>
+              <a:rPr sz="1000" b="0">
+                <a:solidFill>
+                  <a:srgbClr val="C8E0F4"/>
+                </a:solidFill>
+              </a:rPr>
+              <a:t>RCT: phân bổ Voucher ngẫu nhiên</a:t>
+            </a:r>
+          </a:p>
+        </p:txBody>
+      </p:sp>
+      <p:sp>
+        <p:nvSpPr>
+          <p:cNvPr id="21" name="Rectangle 20"/>
+          <p:cNvSpPr/>
+          <p:nvPr/>
+        </p:nvSpPr>
+        <p:spPr>
+          <a:xfrm>
+            <a:off x="6094476" y="5486400"/>
+            <a:ext cx="2841498" cy="621792"/>
+          </a:xfrm>
+          <a:prstGeom prst="rect">
+            <a:avLst/>
+          </a:prstGeom>
+          <a:solidFill>
+            <a:srgbClr val="132642"/>
+          </a:solidFill>
+          <a:ln>
+            <a:noFill/>
+          </a:ln>
+        </p:spPr>
+        <p:style>
+          <a:lnRef idx="1">
+            <a:schemeClr val="accent1"/>
+          </a:lnRef>
+          <a:fillRef idx="3">
+            <a:schemeClr val="accent1"/>
+          </a:fillRef>
+          <a:effectRef idx="2">
+            <a:schemeClr val="accent1"/>
+          </a:effectRef>
+          <a:fontRef idx="minor">
+            <a:schemeClr val="lt1"/>
+          </a:fontRef>
+        </p:style>
+        <p:txBody>
+          <a:bodyPr rtlCol="0" anchor="ctr"/>
+          <a:lstStyle/>
+          <a:p>
+            <a:pPr algn="ctr"/>
+          </a:p>
+        </p:txBody>
+      </p:sp>
+      <p:sp>
+        <p:nvSpPr>
+          <p:cNvPr id="22" name="Rectangle 21"/>
+          <p:cNvSpPr/>
+          <p:nvPr/>
+        </p:nvSpPr>
+        <p:spPr>
+          <a:xfrm>
+            <a:off x="6094476" y="5486400"/>
+            <a:ext cx="2841498" cy="64008"/>
+          </a:xfrm>
+          <a:prstGeom prst="rect">
+            <a:avLst/>
+          </a:prstGeom>
+          <a:solidFill>
+            <a:srgbClr val="00B4D8"/>
+          </a:solidFill>
+          <a:ln>
+            <a:noFill/>
+          </a:ln>
+        </p:spPr>
+        <p:style>
+          <a:lnRef idx="1">
+            <a:schemeClr val="accent1"/>
+          </a:lnRef>
+          <a:fillRef idx="3">
+            <a:schemeClr val="accent1"/>
+          </a:fillRef>
+          <a:effectRef idx="2">
+            <a:schemeClr val="accent1"/>
+          </a:effectRef>
+          <a:fontRef idx="minor">
+            <a:schemeClr val="lt1"/>
+          </a:fontRef>
+        </p:style>
+        <p:txBody>
+          <a:bodyPr rtlCol="0" anchor="ctr"/>
+          <a:lstStyle/>
+          <a:p>
+            <a:pPr algn="ctr"/>
+          </a:p>
+        </p:txBody>
+      </p:sp>
+      <p:sp>
+        <p:nvSpPr>
+          <p:cNvPr id="23" name="TextBox 22"/>
+          <p:cNvSpPr txBox="1"/>
+          <p:nvPr/>
+        </p:nvSpPr>
+        <p:spPr>
+          <a:xfrm>
+            <a:off x="6185916" y="5504688"/>
+            <a:ext cx="2658618" cy="320040"/>
+          </a:xfrm>
+          <a:prstGeom prst="rect">
+            <a:avLst/>
+          </a:prstGeom>
+          <a:noFill/>
+        </p:spPr>
+        <p:txBody>
+          <a:bodyPr wrap="square">
+            <a:spAutoFit/>
+          </a:bodyPr>
+          <a:lstStyle/>
+          <a:p>
+            <a:pPr algn="ctr"/>
+            <a:r>
+              <a:rPr sz="2000" b="1">
+                <a:solidFill>
+                  <a:srgbClr val="FF9F1C"/>
+                </a:solidFill>
+              </a:rPr>
+              <a:t>true_ite</a:t>
+            </a:r>
+          </a:p>
+        </p:txBody>
+      </p:sp>
+      <p:sp>
+        <p:nvSpPr>
+          <p:cNvPr id="24" name="TextBox 23"/>
+          <p:cNvSpPr txBox="1"/>
+          <p:nvPr/>
+        </p:nvSpPr>
+        <p:spPr>
+          <a:xfrm>
+            <a:off x="6185916" y="5833872"/>
+            <a:ext cx="2658618" cy="256032"/>
+          </a:xfrm>
+          <a:prstGeom prst="rect">
+            <a:avLst/>
+          </a:prstGeom>
+          <a:noFill/>
+        </p:spPr>
+        <p:txBody>
+          <a:bodyPr wrap="square">
+            <a:spAutoFit/>
+          </a:bodyPr>
+          <a:lstStyle/>
+          <a:p>
+            <a:pPr algn="ctr"/>
+            <a:r>
+              <a:rPr sz="1000" b="0">
+                <a:solidFill>
+                  <a:srgbClr val="C8E0F4"/>
+                </a:solidFill>
+              </a:rPr>
+              <a:t>Ground Truth ITE từng cá nhân</a:t>
+            </a:r>
+          </a:p>
+        </p:txBody>
+      </p:sp>
+      <p:sp>
+        <p:nvSpPr>
+          <p:cNvPr id="25" name="Rectangle 24"/>
+          <p:cNvSpPr/>
+          <p:nvPr/>
+        </p:nvSpPr>
+        <p:spPr>
+          <a:xfrm>
+            <a:off x="8981694" y="5486400"/>
+            <a:ext cx="2841498" cy="621792"/>
+          </a:xfrm>
+          <a:prstGeom prst="rect">
+            <a:avLst/>
+          </a:prstGeom>
+          <a:solidFill>
+            <a:srgbClr val="132642"/>
+          </a:solidFill>
+          <a:ln>
+            <a:noFill/>
+          </a:ln>
+        </p:spPr>
+        <p:style>
+          <a:lnRef idx="1">
+            <a:schemeClr val="accent1"/>
+          </a:lnRef>
+          <a:fillRef idx="3">
+            <a:schemeClr val="accent1"/>
+          </a:fillRef>
+          <a:effectRef idx="2">
+            <a:schemeClr val="accent1"/>
+          </a:effectRef>
+          <a:fontRef idx="minor">
+            <a:schemeClr val="lt1"/>
+          </a:fontRef>
+        </p:style>
+        <p:txBody>
+          <a:bodyPr rtlCol="0" anchor="ctr"/>
+          <a:lstStyle/>
+          <a:p>
+            <a:pPr algn="ctr"/>
+          </a:p>
+        </p:txBody>
+      </p:sp>
+      <p:sp>
+        <p:nvSpPr>
+          <p:cNvPr id="26" name="Rectangle 25"/>
+          <p:cNvSpPr/>
+          <p:nvPr/>
+        </p:nvSpPr>
+        <p:spPr>
+          <a:xfrm>
+            <a:off x="8981694" y="5486400"/>
+            <a:ext cx="2841498" cy="64008"/>
+          </a:xfrm>
+          <a:prstGeom prst="rect">
+            <a:avLst/>
+          </a:prstGeom>
+          <a:solidFill>
+            <a:srgbClr val="00B4D8"/>
+          </a:solidFill>
+          <a:ln>
+            <a:noFill/>
+          </a:ln>
+        </p:spPr>
+        <p:style>
+          <a:lnRef idx="1">
+            <a:schemeClr val="accent1"/>
+          </a:lnRef>
+          <a:fillRef idx="3">
+            <a:schemeClr val="accent1"/>
+          </a:fillRef>
+          <a:effectRef idx="2">
+            <a:schemeClr val="accent1"/>
+          </a:effectRef>
+          <a:fontRef idx="minor">
+            <a:schemeClr val="lt1"/>
+          </a:fontRef>
+        </p:style>
+        <p:txBody>
+          <a:bodyPr rtlCol="0" anchor="ctr"/>
+          <a:lstStyle/>
+          <a:p>
+            <a:pPr algn="ctr"/>
+          </a:p>
+        </p:txBody>
+      </p:sp>
+      <p:sp>
+        <p:nvSpPr>
+          <p:cNvPr id="27" name="TextBox 26"/>
+          <p:cNvSpPr txBox="1"/>
+          <p:nvPr/>
+        </p:nvSpPr>
+        <p:spPr>
+          <a:xfrm>
+            <a:off x="9073134" y="5504688"/>
+            <a:ext cx="2658618" cy="320040"/>
+          </a:xfrm>
+          <a:prstGeom prst="rect">
+            <a:avLst/>
+          </a:prstGeom>
+          <a:noFill/>
+        </p:spPr>
+        <p:txBody>
+          <a:bodyPr wrap="square">
+            <a:spAutoFit/>
+          </a:bodyPr>
+          <a:lstStyle/>
+          <a:p>
+            <a:pPr algn="ctr"/>
+            <a:r>
+              <a:rPr sz="2000" b="1">
+                <a:solidFill>
+                  <a:srgbClr val="FF9F1C"/>
+                </a:solidFill>
+              </a:rPr>
+              <a:t>Poisson</a:t>
+            </a:r>
+          </a:p>
+        </p:txBody>
+      </p:sp>
+      <p:sp>
+        <p:nvSpPr>
+          <p:cNvPr id="28" name="TextBox 27"/>
+          <p:cNvSpPr txBox="1"/>
+          <p:nvPr/>
+        </p:nvSpPr>
+        <p:spPr>
+          <a:xfrm>
+            <a:off x="9073134" y="5833872"/>
+            <a:ext cx="2658618" cy="256032"/>
+          </a:xfrm>
+          <a:prstGeom prst="rect">
+            <a:avLst/>
+          </a:prstGeom>
+          <a:noFill/>
+        </p:spPr>
+        <p:txBody>
+          <a:bodyPr wrap="square">
+            <a:spAutoFit/>
+          </a:bodyPr>
+          <a:lstStyle/>
+          <a:p>
+            <a:pPr algn="ctr"/>
+            <a:r>
+              <a:rPr sz="1000" b="0">
+                <a:solidFill>
+                  <a:srgbClr val="C8E0F4"/>
+                </a:solidFill>
+              </a:rPr>
+              <a:t>Phân phối nhiễu ngẫu nhiên</a:t>
+            </a:r>
+          </a:p>
+        </p:txBody>
+      </p:sp>
+      <p:sp>
+        <p:nvSpPr>
+          <p:cNvPr id="29" name="Rectangle 28"/>
+          <p:cNvSpPr/>
+          <p:nvPr/>
+        </p:nvSpPr>
+        <p:spPr>
+          <a:xfrm>
+            <a:off x="320040" y="6172200"/>
+            <a:ext cx="11548872" cy="530352"/>
+          </a:xfrm>
+          <a:prstGeom prst="rect">
+            <a:avLst/>
+          </a:prstGeom>
+          <a:solidFill>
+            <a:srgbClr val="0A1A2E"/>
+          </a:solidFill>
+          <a:ln>
+            <a:noFill/>
+          </a:ln>
+        </p:spPr>
+        <p:style>
+          <a:lnRef idx="1">
+            <a:schemeClr val="accent1"/>
+          </a:lnRef>
+          <a:fillRef idx="3">
+            <a:schemeClr val="accent1"/>
+          </a:fillRef>
+          <a:effectRef idx="2">
+            <a:schemeClr val="accent1"/>
+          </a:effectRef>
+          <a:fontRef idx="minor">
+            <a:schemeClr val="lt1"/>
+          </a:fontRef>
+        </p:style>
+        <p:txBody>
+          <a:bodyPr rtlCol="0" anchor="ctr"/>
+          <a:lstStyle/>
+          <a:p>
+            <a:pPr algn="ctr"/>
+          </a:p>
+        </p:txBody>
+      </p:sp>
+      <p:sp>
+        <p:nvSpPr>
+          <p:cNvPr id="30" name="Rectangle 29"/>
+          <p:cNvSpPr/>
+          <p:nvPr/>
+        </p:nvSpPr>
+        <p:spPr>
+          <a:xfrm>
+            <a:off x="320040" y="6172200"/>
+            <a:ext cx="54864" cy="530352"/>
+          </a:xfrm>
+          <a:prstGeom prst="rect">
+            <a:avLst/>
+          </a:prstGeom>
+          <a:solidFill>
+            <a:srgbClr val="48CAA3"/>
+          </a:solidFill>
+          <a:ln>
+            <a:noFill/>
+          </a:ln>
+        </p:spPr>
+        <p:style>
+          <a:lnRef idx="1">
+            <a:schemeClr val="accent1"/>
+          </a:lnRef>
+          <a:fillRef idx="3">
+            <a:schemeClr val="accent1"/>
+          </a:fillRef>
+          <a:effectRef idx="2">
+            <a:schemeClr val="accent1"/>
+          </a:effectRef>
+          <a:fontRef idx="minor">
+            <a:schemeClr val="lt1"/>
+          </a:fontRef>
+        </p:style>
+        <p:txBody>
+          <a:bodyPr rtlCol="0" anchor="ctr"/>
+          <a:lstStyle/>
+          <a:p>
+            <a:pPr algn="ctr"/>
+          </a:p>
+        </p:txBody>
+      </p:sp>
+      <p:sp>
+        <p:nvSpPr>
+          <p:cNvPr id="31" name="TextBox 30"/>
+          <p:cNvSpPr txBox="1"/>
+          <p:nvPr/>
+        </p:nvSpPr>
+        <p:spPr>
+          <a:xfrm>
+            <a:off x="475488" y="6199632"/>
+            <a:ext cx="2286000" cy="411480"/>
+          </a:xfrm>
+          <a:prstGeom prst="rect">
+            <a:avLst/>
+          </a:prstGeom>
+          <a:noFill/>
+        </p:spPr>
+        <p:txBody>
+          <a:bodyPr wrap="square">
+            <a:spAutoFit/>
+          </a:bodyPr>
+          <a:lstStyle/>
+          <a:p>
+            <a:pPr algn="l"/>
+            <a:r>
+              <a:rPr sz="1100" b="1">
+                <a:solidFill>
+                  <a:srgbClr val="48CAA3"/>
+                </a:solidFill>
+              </a:rPr>
+              <a:t>📓  Xem tại Notebook: </a:t>
+            </a:r>
+          </a:p>
+        </p:txBody>
+      </p:sp>
+      <p:sp>
+        <p:nvSpPr>
+          <p:cNvPr id="32" name="TextBox 31"/>
+          <p:cNvSpPr txBox="1"/>
+          <p:nvPr/>
+        </p:nvSpPr>
+        <p:spPr>
+          <a:xfrm>
+            <a:off x="2743200" y="6199632"/>
+            <a:ext cx="5029200" cy="411480"/>
+          </a:xfrm>
+          <a:prstGeom prst="rect">
+            <a:avLst/>
+          </a:prstGeom>
+          <a:noFill/>
+        </p:spPr>
+        <p:txBody>
+          <a:bodyPr wrap="square">
+            <a:spAutoFit/>
+          </a:bodyPr>
+          <a:lstStyle/>
+          <a:p>
+            <a:pPr algn="l"/>
+            <a:r>
+              <a:rPr sz="1100" b="1">
+                <a:solidFill>
+                  <a:srgbClr val="FF9F1C"/>
+                </a:solidFill>
+              </a:rPr>
+              <a:t>2_complex_data_generation.ipynb  </a:t>
+            </a:r>
+          </a:p>
+        </p:txBody>
+      </p:sp>
+      <p:sp>
+        <p:nvSpPr>
+          <p:cNvPr id="33" name="TextBox 32"/>
+          <p:cNvSpPr txBox="1"/>
+          <p:nvPr/>
+        </p:nvSpPr>
+        <p:spPr>
+          <a:xfrm>
+            <a:off x="6949440" y="6199632"/>
+            <a:ext cx="4572000" cy="411480"/>
+          </a:xfrm>
+          <a:prstGeom prst="rect">
+            <a:avLst/>
+          </a:prstGeom>
+          <a:noFill/>
+        </p:spPr>
+        <p:txBody>
+          <a:bodyPr wrap="square">
+            <a:spAutoFit/>
+          </a:bodyPr>
+          <a:lstStyle/>
+          <a:p>
+            <a:pPr algn="l"/>
+            <a:r>
+              <a:rPr sz="1100" b="0">
+                <a:solidFill>
+                  <a:srgbClr val="C8E0F4"/>
+                </a:solidFill>
+              </a:rPr>
+              <a:t>| Mục: Cell 6-7: generate_outcomes() + visualize_distributions()</a:t>
+            </a:r>
+          </a:p>
+        </p:txBody>
+      </p:sp>
+      <p:sp>
+        <p:nvSpPr>
+          <p:cNvPr id="34" name="Rectangle 33"/>
+          <p:cNvSpPr/>
+          <p:nvPr/>
+        </p:nvSpPr>
+        <p:spPr>
+          <a:xfrm>
             <a:off x="0" y="6793992"/>
             <a:ext cx="12188952" cy="64008"/>
           </a:xfrm>
@@ -9053,6 +12457,194 @@
       <p:sp>
         <p:nvSpPr>
           <p:cNvPr id="35" name="Rectangle 34"/>
+          <p:cNvSpPr/>
+          <p:nvPr/>
+        </p:nvSpPr>
+        <p:spPr>
+          <a:xfrm>
+            <a:off x="320040" y="6172200"/>
+            <a:ext cx="11548872" cy="530352"/>
+          </a:xfrm>
+          <a:prstGeom prst="rect">
+            <a:avLst/>
+          </a:prstGeom>
+          <a:solidFill>
+            <a:srgbClr val="0A1A2E"/>
+          </a:solidFill>
+          <a:ln>
+            <a:noFill/>
+          </a:ln>
+        </p:spPr>
+        <p:style>
+          <a:lnRef idx="1">
+            <a:schemeClr val="accent1"/>
+          </a:lnRef>
+          <a:fillRef idx="3">
+            <a:schemeClr val="accent1"/>
+          </a:fillRef>
+          <a:effectRef idx="2">
+            <a:schemeClr val="accent1"/>
+          </a:effectRef>
+          <a:fontRef idx="minor">
+            <a:schemeClr val="lt1"/>
+          </a:fontRef>
+        </p:style>
+        <p:txBody>
+          <a:bodyPr rtlCol="0" anchor="ctr"/>
+          <a:lstStyle/>
+          <a:p>
+            <a:pPr algn="ctr"/>
+          </a:p>
+        </p:txBody>
+      </p:sp>
+      <p:sp>
+        <p:nvSpPr>
+          <p:cNvPr id="36" name="Rectangle 35"/>
+          <p:cNvSpPr/>
+          <p:nvPr/>
+        </p:nvSpPr>
+        <p:spPr>
+          <a:xfrm>
+            <a:off x="320040" y="6172200"/>
+            <a:ext cx="54864" cy="530352"/>
+          </a:xfrm>
+          <a:prstGeom prst="rect">
+            <a:avLst/>
+          </a:prstGeom>
+          <a:solidFill>
+            <a:srgbClr val="48CAA3"/>
+          </a:solidFill>
+          <a:ln>
+            <a:noFill/>
+          </a:ln>
+        </p:spPr>
+        <p:style>
+          <a:lnRef idx="1">
+            <a:schemeClr val="accent1"/>
+          </a:lnRef>
+          <a:fillRef idx="3">
+            <a:schemeClr val="accent1"/>
+          </a:fillRef>
+          <a:effectRef idx="2">
+            <a:schemeClr val="accent1"/>
+          </a:effectRef>
+          <a:fontRef idx="minor">
+            <a:schemeClr val="lt1"/>
+          </a:fontRef>
+        </p:style>
+        <p:txBody>
+          <a:bodyPr rtlCol="0" anchor="ctr"/>
+          <a:lstStyle/>
+          <a:p>
+            <a:pPr algn="ctr"/>
+          </a:p>
+        </p:txBody>
+      </p:sp>
+      <p:sp>
+        <p:nvSpPr>
+          <p:cNvPr id="37" name="TextBox 36"/>
+          <p:cNvSpPr txBox="1"/>
+          <p:nvPr/>
+        </p:nvSpPr>
+        <p:spPr>
+          <a:xfrm>
+            <a:off x="475488" y="6199632"/>
+            <a:ext cx="2286000" cy="411480"/>
+          </a:xfrm>
+          <a:prstGeom prst="rect">
+            <a:avLst/>
+          </a:prstGeom>
+          <a:noFill/>
+        </p:spPr>
+        <p:txBody>
+          <a:bodyPr wrap="square">
+            <a:spAutoFit/>
+          </a:bodyPr>
+          <a:lstStyle/>
+          <a:p>
+            <a:pPr algn="l"/>
+            <a:r>
+              <a:rPr sz="1100" b="1">
+                <a:solidFill>
+                  <a:srgbClr val="48CAA3"/>
+                </a:solidFill>
+              </a:rPr>
+              <a:t>📓  Xem tại Notebook: </a:t>
+            </a:r>
+          </a:p>
+        </p:txBody>
+      </p:sp>
+      <p:sp>
+        <p:nvSpPr>
+          <p:cNvPr id="38" name="TextBox 37"/>
+          <p:cNvSpPr txBox="1"/>
+          <p:nvPr/>
+        </p:nvSpPr>
+        <p:spPr>
+          <a:xfrm>
+            <a:off x="2743200" y="6199632"/>
+            <a:ext cx="5029200" cy="411480"/>
+          </a:xfrm>
+          <a:prstGeom prst="rect">
+            <a:avLst/>
+          </a:prstGeom>
+          <a:noFill/>
+        </p:spPr>
+        <p:txBody>
+          <a:bodyPr wrap="square">
+            <a:spAutoFit/>
+          </a:bodyPr>
+          <a:lstStyle/>
+          <a:p>
+            <a:pPr algn="l"/>
+            <a:r>
+              <a:rPr sz="1100" b="1">
+                <a:solidFill>
+                  <a:srgbClr val="FF9F1C"/>
+                </a:solidFill>
+              </a:rPr>
+              <a:t>1_confounding_demo.ipynb  +  2_complex_data_generation.ipynb  </a:t>
+            </a:r>
+          </a:p>
+        </p:txBody>
+      </p:sp>
+      <p:sp>
+        <p:nvSpPr>
+          <p:cNvPr id="39" name="TextBox 38"/>
+          <p:cNvSpPr txBox="1"/>
+          <p:nvPr/>
+        </p:nvSpPr>
+        <p:spPr>
+          <a:xfrm>
+            <a:off x="6949440" y="6199632"/>
+            <a:ext cx="4572000" cy="411480"/>
+          </a:xfrm>
+          <a:prstGeom prst="rect">
+            <a:avLst/>
+          </a:prstGeom>
+          <a:noFill/>
+        </p:spPr>
+        <p:txBody>
+          <a:bodyPr wrap="square">
+            <a:spAutoFit/>
+          </a:bodyPr>
+          <a:lstStyle/>
+          <a:p>
+            <a:pPr algn="l"/>
+            <a:r>
+              <a:rPr sz="1100" b="0">
+                <a:solidFill>
+                  <a:srgbClr val="C8E0F4"/>
+                </a:solidFill>
+              </a:rPr>
+              <a:t>| Mục: Chay tuan tu 2 notebooks de thay toan bo pipeline</a:t>
+            </a:r>
+          </a:p>
+        </p:txBody>
+      </p:sp>
+      <p:sp>
+        <p:nvSpPr>
+          <p:cNvPr id="40" name="Rectangle 39"/>
           <p:cNvSpPr/>
           <p:nvPr/>
         </p:nvSpPr>

</xml_diff>

<commit_message>
feat(experimentation): Finalize A/B & A/A test pipelines and clean debug scripts
</commit_message>
<xml_diff>
--- a/docs/Week2_Synthetic_Data_Deck_v2.pptx
+++ b/docs/Week2_Synthetic_Data_Deck_v2.pptx
@@ -8743,7 +8743,7 @@
                   <a:srgbClr val="C8E0F4"/>
                 </a:solidFill>
               </a:rPr>
-              <a:t>• Urban Regulars (Rush Hour)  →  ITE ≈ +1.0</a:t>
+              <a:t>• Urban Cash (Rush Hour)  →  ITE ≈ +1.0</a:t>
             </a:r>
           </a:p>
           <a:p>
@@ -8942,7 +8942,7 @@
                   <a:srgbClr val="C8E0F4"/>
                 </a:solidFill>
               </a:rPr>
-              <a:t>• Urban Leisure  →  ITE ≈ +2.5</a:t>
+              <a:t>• Urban Credit Card  →  ITE ≈ +2.5</a:t>
             </a:r>
           </a:p>
           <a:p>
@@ -9283,7 +9283,7 @@
                   <a:srgbClr val="C8E0F4"/>
                 </a:solidFill>
               </a:rPr>
-              <a:t>Urban Regulars (đi làm)</a:t>
+              <a:t>Urban Cash (đi làm)</a:t>
             </a:r>
           </a:p>
         </p:txBody>
@@ -9437,7 +9437,7 @@
                   <a:srgbClr val="C8E0F4"/>
                 </a:solidFill>
               </a:rPr>
-              <a:t>Urban Leisure (nhạy cảm giá)</a:t>
+              <a:t>Urban Credit Card (nhạy cảm giá)</a:t>
             </a:r>
           </a:p>
         </p:txBody>

</xml_diff>

<commit_message>
chore: cleanup slide drafts, add mega presentation decks, and sync week2 reports with EDA findings
</commit_message>
<xml_diff>
--- a/docs/Week2_Synthetic_Data_Deck_v2.pptx
+++ b/docs/Week2_Synthetic_Data_Deck_v2.pptx
@@ -3665,7 +3665,7 @@
                   <a:srgbClr val="C8E0F4"/>
                 </a:solidFill>
               </a:rPr>
-              <a:t>• Mô phỏng 20,000 khách hàng với Raw Features thực tế</a:t>
+              <a:t>Mô phỏng 20,000 khách hàng — tham số kế thừa từ EDA T1 (Avg Fare $17.60, Median $13.50)</a:t>
             </a:r>
           </a:p>
           <a:p>
@@ -5408,7 +5408,7 @@
                   <a:srgbClr val="C8E0F4"/>
                 </a:solidFill>
               </a:rPr>
-              <a:t>Proxy cho Thu nhập. Cuốc sân bay × 4</a:t>
+              <a:t>Proxy cho Thu nhập. Avg Fare = $17.60 (EDA T1). Cuốc sân bay × 4</a:t>
             </a:r>
           </a:p>
         </p:txBody>
@@ -6101,7 +6101,7 @@
                   <a:srgbClr val="C8E0F4"/>
                 </a:solidFill>
               </a:rPr>
-              <a:t>Đỉnh chóp vào giờ cao điểm</a:t>
+              <a:t>Đỉnh giờ cao điểm — xác suất kế thừa từ EDA T1</a:t>
             </a:r>
           </a:p>
         </p:txBody>
@@ -11484,7 +11484,7 @@
                   <a:srgbClr val="C8E0F4"/>
                 </a:solidFill>
               </a:rPr>
-              <a:t>✔ Thiết kế SCM, gài luật HTE vào Raw Features, tạo Ground Truth</a:t>
+              <a:t>⬛ Thiết kế SCM, gài luật HTE vào Raw Features, tạo Ground Truth + Kiểm định Covariate Balance</a:t>
             </a:r>
           </a:p>
         </p:txBody>

</xml_diff>